<commit_message>
docs(slides): one slide per research question, each with its chart
- RQ1: new figure fig_rq1_category, blind retry vs diagnostics per error
  category at k=1, generated from run records by generate_figures.py
- RQ2: cost-quality Pareto chart with the three key points
- RQ3: worker speedup chart with REPL and 10K throughput/P95 numbers
- appendix: P1 ablation (compile vs audited success), P2 P50/P95 latency
  across the three data tiers
- 15 main slides + 2 appendix

Co-Authored-By: Claude Opus 5.5 <noreply@anthropic.com>
</commit_message>
<xml_diff>
--- a/slides/Slides_Nhom6_VerifierRepair.pptx
+++ b/slides/Slides_Nhom6_VerifierRepair.pptx
@@ -21,6 +21,7 @@
     <p:sldId id="269" r:id="rId21"/>
     <p:sldId id="270" r:id="rId22"/>
     <p:sldId id="271" r:id="rId23"/>
+    <p:sldId id="272" r:id="rId24"/>
   </p:sldIdLst>
   <p:sldSz cx="12191695" cy="6858000" type="screen4x3"/>
   <p:notesSz cx="6858000" cy="9144000"/>
@@ -587,7 +588,7 @@
           <a:lstStyle/>
           <a:p>
             <a:r>
-              <a:t>Trung + Khamsing: luật được thử trước trên 203/284 mẫu nhưng chỉ đúng 33%; với k = 1 luật sai là hết lượt. R0 97%, R7 100%; R2–R6 0% trên tệp hoàn chỉnh. Ablation bộ phân loại phát lại log, không gọi thêm LLM: phân loại đúng hơn giảm 31% token nhưng gửi nhiều mẫu hơn sang luật kém. Cải tiến: chỉ dùng luật chính xác, đo trên train.</a:t>
+              <a:t>Tâm: trục x là chi phí LLM cho 1.000 mẫu, trục y là tỷ lệ thành công. Biên đi từ chỉ luật $0 qua lai k=1, LLM k=1, lai k=3 tới LLM k=3. Blind và Gemini 3.6 Flash nằm dưới biên: đắt hơn mà kém hơn. k = 3 thêm 11 điểm so với k = 1; 82,7% thành công đến ngay lần thử đầu. Biểu đồ ablation đầy đủ ở phụ lục P1.</a:t>
             </a:r>
           </a:p>
         </p:txBody>
@@ -657,7 +658,7 @@
           <a:lstStyle/>
           <a:p>
             <a:r>
-              <a:t>Khamsing/Tâm: trong các mẫu thất bại, 17–26% bản sửa của LLM đổi phát biểu và 10–24% chèn sorry hoặc cấu trúc cấm. LLM k = 3: biên dịch 75,0% nhưng thành công thật 65,1%.</a:t>
+              <a:t>Dũng: REPL khớp 74/74 với chạy nguội. 3 mức dữ liệu x 3 mức worker x 3 lần lặp, chênh lệch dưới 4%. Từ 2 lên 4 worker chỉ thêm 7–11% thông lượng, P95 phục vụ tăng gấp đôi vì 4 REPL tranh 4 vCPU. USS 12,6 → 21,1 GB. Mở rộng tiếp cần nhiều máy. P50 và P95 theo từng mức ở phụ lục P2.</a:t>
             </a:r>
           </a:p>
         </p:txBody>
@@ -727,7 +728,7 @@
           <a:lstStyle/>
           <a:p>
             <a:r>
-              <a:t>Tâm: ba bài học; phần bàn giao và tái lập: scripts/repair_batch.py nhận file của Nhóm 5 theo data contract, đầu ra repaired-v1 cho Nhóm 7/8, Docker, 121 test, notebook Kaggle, run record và log phát lại; hướng phát triển.</a:t>
+              <a:t>Trung + Khamsing: luật được thử trước trên 203/284 mẫu nhưng chỉ đúng 33%; với k = 1 luật sai là hết lượt. R0 97%, R7 100%; R2–R6 0% trên tệp hoàn chỉnh. Ablation bộ phân loại phát lại log, không gọi thêm LLM: phân loại đúng hơn giảm 31% token nhưng gửi nhiều mẫu hơn sang luật kém. Cải tiến: chỉ dùng luật chính xác, đo trên train.</a:t>
             </a:r>
           </a:p>
         </p:txBody>
@@ -797,7 +798,7 @@
           <a:lstStyle/>
           <a:p>
             <a:r>
-              <a:t>Cả nhóm: cảm ơn, mời hỏi đáp; Tâm điều phối người trả lời theo bảng; bộ câu hỏi trong slides/defense_qa.md. Phụ lục P1–P3 sau slide này, chỉ mở khi được hỏi về biểu đồ.</a:t>
+              <a:t>Khamsing/Tâm: trong các mẫu thất bại, 17–26% bản sửa của LLM đổi phát biểu và 10–24% chèn sorry hoặc cấu trúc cấm. LLM k = 3: biên dịch 75,0% nhưng thành công thật 65,1%.</a:t>
             </a:r>
           </a:p>
         </p:txBody>
@@ -867,7 +868,7 @@
           <a:lstStyle/>
           <a:p>
             <a:r>
-              <a:t>Cột xanh là biên dịch, cột cam là thành công đã kiểm toán. k = 3 thêm 11 điểm % so với k = 1; 82,7% thành công đến ngay lần thử đầu, 12,4% ở lần 2.</a:t>
+              <a:t>Tâm: ba bài học; phần bàn giao và tái lập: scripts/repair_batch.py nhận file của Nhóm 5 theo data contract, đầu ra repaired-v1 cho Nhóm 7/8, Docker, 121 test, notebook Kaggle, run record và log phát lại; hướng phát triển.</a:t>
             </a:r>
           </a:p>
         </p:txBody>
@@ -937,7 +938,7 @@
           <a:lstStyle/>
           <a:p>
             <a:r>
-              <a:t>Trục x là chi phí LLM cho 1.000 mẫu, trục y là tỷ lệ thành công. Blind và mô hình 3.6 Flash nằm dưới biên.</a:t>
+              <a:t>Cả nhóm: cảm ơn, mời hỏi đáp; Tâm điều phối người trả lời theo bảng; bộ câu hỏi trong slides/defense_qa.md. Phụ lục P1–P2 sau slide này, chỉ mở khi được hỏi.</a:t>
             </a:r>
           </a:p>
         </p:txBody>
@@ -1007,7 +1008,77 @@
           <a:lstStyle/>
           <a:p>
             <a:r>
-              <a:t>REPL khớp 74/74 với chạy nguội. 3 mức x 3 mức worker x 3 lần lặp, chênh lệch dưới 4%. USS 12,6 → 21,1 GB. Mở rộng tiếp cần nhiều máy.</a:t>
+              <a:t>Cột xanh là biên dịch, cột cam là thành công đã kiểm toán; khoảng cách giữa hai cột là phần kiểm toán chặn. k = 3 thêm 11 điểm % so với k = 1; 82,7% thành công đến ngay lần thử đầu, 12,4% ở lần 2.</a:t>
+            </a:r>
+          </a:p>
+        </p:txBody>
+      </p:sp>
+      <p:sp>
+        <p:nvSpPr>
+          <p:cNvPr id="4" name="Slide Number Placeholder 3"/>
+          <p:cNvSpPr>
+            <a:spLocks noGrp="1"/>
+          </p:cNvSpPr>
+          <p:nvPr>
+            <p:ph type="sldNum" idx="5" sz="quarter"/>
+          </p:nvPr>
+        </p:nvSpPr>
+        <p:spPr/>
+      </p:sp>
+    </p:spTree>
+  </p:cSld>
+  <p:clrMapOvr>
+    <a:masterClrMapping/>
+  </p:clrMapOvr>
+</p:notes>
+</file>
+
+<file path=ppt/notesSlides/notesSlide17.xml><?xml version="1.0" encoding="utf-8"?>
+<p:notes xmlns:a="http://schemas.openxmlformats.org/drawingml/2006/main" xmlns:p="http://schemas.openxmlformats.org/presentationml/2006/main" xmlns:r="http://schemas.openxmlformats.org/officeDocument/2006/relationships">
+  <p:cSld>
+    <p:spTree>
+      <p:nvGrpSpPr>
+        <p:cNvPr id="1" name=""/>
+        <p:cNvGrpSpPr/>
+        <p:nvPr/>
+      </p:nvGrpSpPr>
+      <p:grpSpPr>
+        <a:xfrm>
+          <a:off x="0" y="0"/>
+          <a:ext cx="0" cy="0"/>
+          <a:chOff x="0" y="0"/>
+          <a:chExt cx="0" cy="0"/>
+        </a:xfrm>
+      </p:grpSpPr>
+      <p:sp>
+        <p:nvSpPr>
+          <p:cNvPr id="2" name="Slide Image Placeholder 1"/>
+          <p:cNvSpPr>
+            <a:spLocks noGrp="1"/>
+          </p:cNvSpPr>
+          <p:nvPr>
+            <p:ph type="sldImg" idx="2"/>
+          </p:nvPr>
+        </p:nvSpPr>
+        <p:spPr/>
+      </p:sp>
+      <p:sp>
+        <p:nvSpPr>
+          <p:cNvPr id="3" name="Notes Placeholder 2"/>
+          <p:cNvSpPr>
+            <a:spLocks noGrp="1"/>
+          </p:cNvSpPr>
+          <p:nvPr>
+            <p:ph type="body" idx="3" sz="quarter"/>
+          </p:nvPr>
+        </p:nvSpPr>
+        <p:spPr/>
+        <p:txBody>
+          <a:bodyPr/>
+          <a:lstStyle/>
+          <a:p>
+            <a:r>
+              <a:t>P50 và P95 thời gian phục vụ mỗi mẫu ở 100, 1K, 10K với 1, 2, 4 worker, trung vị và min–max của 3 lần lặp. Ở mức 100 P95 cao vì mẫu ít, đuôi do vài định lý nặng chi phối.</a:t>
             </a:r>
           </a:p>
         </p:txBody>
@@ -1567,7 +1638,7 @@
           <a:lstStyle/>
           <a:p>
             <a:r>
-              <a:t>Tâm/Tùng/Dũng: RQ1 cùng 284 mẫu hold-out, k = 1: không có chẩn đoán mô hình viết lại cả tệp, 783 token ra, có chẩn đoán chỉ 389. RQ2: k = 3 thêm 11 điểm, Pareto đi từ chỉ luật $0 tới LLM k=3. RQ3: 3 mức x 3 mức worker x 3 lần lặp; từ 2 lên 4 worker chỉ thêm 7–11% thông lượng vì 4 REPL tranh 4 vCPU. Biểu đồ chi tiết ở phụ lục P1–P3.</a:t>
+              <a:t>Tùng: cùng 284 mẫu hold-out, k = 1, cùng model. Không có chẩn đoán, mô hình viết lại cả tệp, 783 token ra mỗi lần nên đắt hơn; có chẩn đoán, mô hình sửa cục bộ, 389 token. Lợi ích lớn ở SYN_01 47 → 85%, TMO_05 10 → 69%, IMP_02 3 → 34%; SEM_06 và TAC_07 hơi kém hơn vì cần viết chứng minh mới chứ không chỉ sửa chỗ lỗi.</a:t>
             </a:r>
           </a:p>
         </p:txBody>
@@ -4994,7 +5065,7 @@
                 </a:solidFill>
                 <a:latin typeface="Helvetica"/>
               </a:rPr>
-              <a:t>Phân tích: luật đúng gần hoàn hảo, luật sai kéo chiến lược lai xuống</a:t>
+              <a:t>RQ2: LLM có chẩn đoán, thử 3 lần đạt 65,1%, nằm trên biên Pareto</a:t>
             </a:r>
           </a:p>
         </p:txBody>
@@ -5034,6 +5105,930 @@
                 <a:latin typeface="Helvetica"/>
               </a:rPr>
               <a:t>10</a:t>
+            </a:r>
+          </a:p>
+        </p:txBody>
+      </p:sp>
+      <p:pic>
+        <p:nvPicPr>
+          <p:cNvPr id="6" name="Picture 5" descr="fig_cost_quality_slide.png"/>
+          <p:cNvPicPr>
+            <a:picLocks noChangeAspect="1"/>
+          </p:cNvPicPr>
+          <p:nvPr/>
+        </p:nvPicPr>
+        <p:blipFill>
+          <a:blip r:embed="rId3"/>
+          <a:stretch>
+            <a:fillRect/>
+          </a:stretch>
+        </p:blipFill>
+        <p:spPr>
+          <a:xfrm>
+            <a:off x="457200" y="1691640"/>
+            <a:ext cx="7680960" cy="4416255"/>
+          </a:xfrm>
+          <a:prstGeom prst="rect">
+            <a:avLst/>
+          </a:prstGeom>
+        </p:spPr>
+      </p:pic>
+      <p:sp>
+        <p:nvSpPr>
+          <p:cNvPr id="7" name="TextBox 6"/>
+          <p:cNvSpPr txBox="1"/>
+          <p:nvPr/>
+        </p:nvSpPr>
+        <p:spPr>
+          <a:xfrm>
+            <a:off x="8412480" y="1737360"/>
+            <a:ext cx="3291840" cy="685800"/>
+          </a:xfrm>
+          <a:prstGeom prst="rect">
+            <a:avLst/>
+          </a:prstGeom>
+          <a:noFill/>
+        </p:spPr>
+        <p:txBody>
+          <a:bodyPr wrap="square" anchor="t" lIns="45720" rIns="45720" tIns="27432" bIns="27432">
+            <a:spAutoFit/>
+          </a:bodyPr>
+          <a:lstStyle/>
+          <a:p>
+            <a:pPr algn="l">
+              <a:lnSpc>
+                <a:spcPct val="110000"/>
+              </a:lnSpc>
+            </a:pPr>
+            <a:r>
+              <a:rPr sz="3600" b="1" i="0">
+                <a:solidFill>
+                  <a:srgbClr val="144FB0"/>
+                </a:solidFill>
+                <a:latin typeface="Helvetica"/>
+              </a:rPr>
+              <a:t>65,1%</a:t>
+            </a:r>
+          </a:p>
+        </p:txBody>
+      </p:sp>
+      <p:sp>
+        <p:nvSpPr>
+          <p:cNvPr id="8" name="TextBox 7"/>
+          <p:cNvSpPr txBox="1"/>
+          <p:nvPr/>
+        </p:nvSpPr>
+        <p:spPr>
+          <a:xfrm>
+            <a:off x="8412480" y="2395728"/>
+            <a:ext cx="3291840" cy="731520"/>
+          </a:xfrm>
+          <a:prstGeom prst="rect">
+            <a:avLst/>
+          </a:prstGeom>
+          <a:noFill/>
+        </p:spPr>
+        <p:txBody>
+          <a:bodyPr wrap="square" anchor="t" lIns="45720" rIns="45720" tIns="27432" bIns="27432">
+            <a:spAutoFit/>
+          </a:bodyPr>
+          <a:lstStyle/>
+          <a:p>
+            <a:pPr algn="l">
+              <a:lnSpc>
+                <a:spcPct val="110000"/>
+              </a:lnSpc>
+            </a:pPr>
+            <a:r>
+              <a:rPr sz="2000" b="0" i="0">
+                <a:solidFill>
+                  <a:srgbClr val="5B6B82"/>
+                </a:solidFill>
+                <a:latin typeface="Helvetica"/>
+              </a:rPr>
+              <a:t>LLM k=3, $2,45 / 1K mẫu</a:t>
+            </a:r>
+          </a:p>
+        </p:txBody>
+      </p:sp>
+      <p:sp>
+        <p:nvSpPr>
+          <p:cNvPr id="9" name="TextBox 8"/>
+          <p:cNvSpPr txBox="1"/>
+          <p:nvPr/>
+        </p:nvSpPr>
+        <p:spPr>
+          <a:xfrm>
+            <a:off x="8412480" y="3200400"/>
+            <a:ext cx="3291840" cy="685800"/>
+          </a:xfrm>
+          <a:prstGeom prst="rect">
+            <a:avLst/>
+          </a:prstGeom>
+          <a:noFill/>
+        </p:spPr>
+        <p:txBody>
+          <a:bodyPr wrap="square" anchor="t" lIns="45720" rIns="45720" tIns="27432" bIns="27432">
+            <a:spAutoFit/>
+          </a:bodyPr>
+          <a:lstStyle/>
+          <a:p>
+            <a:pPr algn="l">
+              <a:lnSpc>
+                <a:spcPct val="110000"/>
+              </a:lnSpc>
+            </a:pPr>
+            <a:r>
+              <a:rPr sz="3600" b="1" i="0">
+                <a:solidFill>
+                  <a:srgbClr val="1E6FE8"/>
+                </a:solidFill>
+                <a:latin typeface="Helvetica"/>
+              </a:rPr>
+              <a:t>59,5%</a:t>
+            </a:r>
+          </a:p>
+        </p:txBody>
+      </p:sp>
+      <p:sp>
+        <p:nvSpPr>
+          <p:cNvPr id="10" name="TextBox 9"/>
+          <p:cNvSpPr txBox="1"/>
+          <p:nvPr/>
+        </p:nvSpPr>
+        <p:spPr>
+          <a:xfrm>
+            <a:off x="8412480" y="3858768"/>
+            <a:ext cx="3291840" cy="731520"/>
+          </a:xfrm>
+          <a:prstGeom prst="rect">
+            <a:avLst/>
+          </a:prstGeom>
+          <a:noFill/>
+        </p:spPr>
+        <p:txBody>
+          <a:bodyPr wrap="square" anchor="t" lIns="45720" rIns="45720" tIns="27432" bIns="27432">
+            <a:spAutoFit/>
+          </a:bodyPr>
+          <a:lstStyle/>
+          <a:p>
+            <a:pPr algn="l">
+              <a:lnSpc>
+                <a:spcPct val="110000"/>
+              </a:lnSpc>
+            </a:pPr>
+            <a:r>
+              <a:rPr sz="2000" b="0" i="0">
+                <a:solidFill>
+                  <a:srgbClr val="5B6B82"/>
+                </a:solidFill>
+                <a:latin typeface="Helvetica"/>
+              </a:rPr>
+              <a:t>lai k=3, rẻ hơn</a:t>
+            </a:r>
+          </a:p>
+        </p:txBody>
+      </p:sp>
+      <p:sp>
+        <p:nvSpPr>
+          <p:cNvPr id="11" name="TextBox 10"/>
+          <p:cNvSpPr txBox="1"/>
+          <p:nvPr/>
+        </p:nvSpPr>
+        <p:spPr>
+          <a:xfrm>
+            <a:off x="8412480" y="4663440"/>
+            <a:ext cx="3291840" cy="685800"/>
+          </a:xfrm>
+          <a:prstGeom prst="rect">
+            <a:avLst/>
+          </a:prstGeom>
+          <a:noFill/>
+        </p:spPr>
+        <p:txBody>
+          <a:bodyPr wrap="square" anchor="t" lIns="45720" rIns="45720" tIns="27432" bIns="27432">
+            <a:spAutoFit/>
+          </a:bodyPr>
+          <a:lstStyle/>
+          <a:p>
+            <a:pPr algn="l">
+              <a:lnSpc>
+                <a:spcPct val="110000"/>
+              </a:lnSpc>
+            </a:pPr>
+            <a:r>
+              <a:rPr sz="3600" b="1" i="0">
+                <a:solidFill>
+                  <a:srgbClr val="5B6B82"/>
+                </a:solidFill>
+                <a:latin typeface="Helvetica"/>
+              </a:rPr>
+              <a:t>23,9%</a:t>
+            </a:r>
+          </a:p>
+        </p:txBody>
+      </p:sp>
+      <p:sp>
+        <p:nvSpPr>
+          <p:cNvPr id="12" name="TextBox 11"/>
+          <p:cNvSpPr txBox="1"/>
+          <p:nvPr/>
+        </p:nvSpPr>
+        <p:spPr>
+          <a:xfrm>
+            <a:off x="8412480" y="5321807"/>
+            <a:ext cx="3291840" cy="731520"/>
+          </a:xfrm>
+          <a:prstGeom prst="rect">
+            <a:avLst/>
+          </a:prstGeom>
+          <a:noFill/>
+        </p:spPr>
+        <p:txBody>
+          <a:bodyPr wrap="square" anchor="t" lIns="45720" rIns="45720" tIns="27432" bIns="27432">
+            <a:spAutoFit/>
+          </a:bodyPr>
+          <a:lstStyle/>
+          <a:p>
+            <a:pPr algn="l">
+              <a:lnSpc>
+                <a:spcPct val="110000"/>
+              </a:lnSpc>
+            </a:pPr>
+            <a:r>
+              <a:rPr sz="2000" b="0" i="0">
+                <a:solidFill>
+                  <a:srgbClr val="5B6B82"/>
+                </a:solidFill>
+                <a:latin typeface="Helvetica"/>
+              </a:rPr>
+              <a:t>chỉ luật, $0</a:t>
+            </a:r>
+          </a:p>
+        </p:txBody>
+      </p:sp>
+    </p:spTree>
+  </p:cSld>
+  <p:clrMapOvr>
+    <a:masterClrMapping/>
+  </p:clrMapOvr>
+  <mc:AlternateContent xmlns:mc="http://schemas.openxmlformats.org/markup-compatibility/2006">
+    <mc:Choice xmlns:p159="http://schemas.microsoft.com/office/powerpoint/2015/09/main" xmlns:p14="http://schemas.microsoft.com/office/powerpoint/2010/main" Requires="p159">
+      <p:transition spd="slow" p14:dur="1200">
+        <p159:morph option="byObject"/>
+      </p:transition>
+    </mc:Choice>
+    <mc:Fallback>
+      <p:transition spd="slow">
+        <p:fade/>
+      </p:transition>
+    </mc:Fallback>
+  </mc:AlternateContent>
+</p:sld>
+</file>
+
+<file path=ppt/slides/slide11.xml><?xml version="1.0" encoding="utf-8"?>
+<p:sld xmlns:a="http://schemas.openxmlformats.org/drawingml/2006/main" xmlns:p="http://schemas.openxmlformats.org/presentationml/2006/main" xmlns:r="http://schemas.openxmlformats.org/officeDocument/2006/relationships">
+  <p:cSld>
+    <p:bg>
+      <p:bgPr>
+        <a:solidFill>
+          <a:srgbClr val="FFFFFF"/>
+        </a:solidFill>
+        <a:effectLst/>
+      </p:bgPr>
+    </p:bg>
+    <p:spTree>
+      <p:nvGrpSpPr>
+        <p:cNvPr id="1" name=""/>
+        <p:cNvGrpSpPr/>
+        <p:nvPr/>
+      </p:nvGrpSpPr>
+      <p:grpSpPr/>
+      <p:sp>
+        <p:nvSpPr>
+          <p:cNvPr id="2" name="!!orb"/>
+          <p:cNvSpPr/>
+          <p:nvPr/>
+        </p:nvSpPr>
+        <p:spPr>
+          <a:xfrm>
+            <a:off x="10058400" y="-2103120"/>
+            <a:ext cx="4023360" cy="4023360"/>
+          </a:xfrm>
+          <a:prstGeom prst="ellipse">
+            <a:avLst/>
+          </a:prstGeom>
+          <a:solidFill>
+            <a:srgbClr val="EAF2FF"/>
+          </a:solidFill>
+          <a:ln>
+            <a:noFill/>
+          </a:ln>
+          <a:effectLst/>
+        </p:spPr>
+        <p:style>
+          <a:lnRef idx="1">
+            <a:schemeClr val="accent1"/>
+          </a:lnRef>
+          <a:fillRef idx="3">
+            <a:schemeClr val="accent1"/>
+          </a:fillRef>
+          <a:effectRef idx="2">
+            <a:schemeClr val="accent1"/>
+          </a:effectRef>
+          <a:fontRef idx="minor">
+            <a:schemeClr val="lt1"/>
+          </a:fontRef>
+        </p:style>
+        <p:txBody>
+          <a:bodyPr rtlCol="0" anchor="ctr"/>
+          <a:lstStyle/>
+          <a:p>
+            <a:pPr algn="ctr"/>
+          </a:p>
+        </p:txBody>
+      </p:sp>
+      <p:sp>
+        <p:nvSpPr>
+          <p:cNvPr id="3" name="!!dot"/>
+          <p:cNvSpPr/>
+          <p:nvPr/>
+        </p:nvSpPr>
+        <p:spPr>
+          <a:xfrm>
+            <a:off x="11247120" y="502920"/>
+            <a:ext cx="411480" cy="411480"/>
+          </a:xfrm>
+          <a:prstGeom prst="ellipse">
+            <a:avLst/>
+          </a:prstGeom>
+          <a:solidFill>
+            <a:srgbClr val="1E6FE8"/>
+          </a:solidFill>
+          <a:ln>
+            <a:noFill/>
+          </a:ln>
+          <a:effectLst/>
+        </p:spPr>
+        <p:style>
+          <a:lnRef idx="1">
+            <a:schemeClr val="accent1"/>
+          </a:lnRef>
+          <a:fillRef idx="3">
+            <a:schemeClr val="accent1"/>
+          </a:fillRef>
+          <a:effectRef idx="2">
+            <a:schemeClr val="accent1"/>
+          </a:effectRef>
+          <a:fontRef idx="minor">
+            <a:schemeClr val="lt1"/>
+          </a:fontRef>
+        </p:style>
+        <p:txBody>
+          <a:bodyPr rtlCol="0" anchor="ctr"/>
+          <a:lstStyle/>
+          <a:p>
+            <a:pPr algn="ctr"/>
+          </a:p>
+        </p:txBody>
+      </p:sp>
+      <p:sp>
+        <p:nvSpPr>
+          <p:cNvPr id="4" name="!!title"/>
+          <p:cNvSpPr txBox="1"/>
+          <p:nvPr/>
+        </p:nvSpPr>
+        <p:spPr>
+          <a:xfrm>
+            <a:off x="548640" y="347472"/>
+            <a:ext cx="10424160" cy="1143000"/>
+          </a:xfrm>
+          <a:prstGeom prst="rect">
+            <a:avLst/>
+          </a:prstGeom>
+          <a:noFill/>
+        </p:spPr>
+        <p:txBody>
+          <a:bodyPr wrap="square" anchor="ctr" lIns="45720" rIns="45720" tIns="27432" bIns="27432">
+            <a:spAutoFit/>
+          </a:bodyPr>
+          <a:lstStyle/>
+          <a:p>
+            <a:pPr algn="l">
+              <a:lnSpc>
+                <a:spcPct val="110000"/>
+              </a:lnSpc>
+            </a:pPr>
+            <a:r>
+              <a:rPr sz="3200" b="1" i="0">
+                <a:solidFill>
+                  <a:srgbClr val="0F1C3F"/>
+                </a:solidFill>
+                <a:latin typeface="Helvetica"/>
+              </a:rPr>
+              <a:t>RQ3: REPL nhanh 3–4 bậc; 4 worker chỉ nhanh 1,88× vì nghẽn CPU</a:t>
+            </a:r>
+          </a:p>
+        </p:txBody>
+      </p:sp>
+      <p:sp>
+        <p:nvSpPr>
+          <p:cNvPr id="5" name="!!num"/>
+          <p:cNvSpPr txBox="1"/>
+          <p:nvPr/>
+        </p:nvSpPr>
+        <p:spPr>
+          <a:xfrm>
+            <a:off x="10881360" y="6236208"/>
+            <a:ext cx="914400" cy="457200"/>
+          </a:xfrm>
+          <a:prstGeom prst="rect">
+            <a:avLst/>
+          </a:prstGeom>
+          <a:noFill/>
+        </p:spPr>
+        <p:txBody>
+          <a:bodyPr wrap="square" anchor="t" lIns="45720" rIns="45720" tIns="27432" bIns="27432">
+            <a:spAutoFit/>
+          </a:bodyPr>
+          <a:lstStyle/>
+          <a:p>
+            <a:pPr algn="r">
+              <a:lnSpc>
+                <a:spcPct val="110000"/>
+              </a:lnSpc>
+            </a:pPr>
+            <a:r>
+              <a:rPr sz="2000" b="0" i="0">
+                <a:solidFill>
+                  <a:srgbClr val="5B6B82"/>
+                </a:solidFill>
+                <a:latin typeface="Helvetica"/>
+              </a:rPr>
+              <a:t>11</a:t>
+            </a:r>
+          </a:p>
+        </p:txBody>
+      </p:sp>
+      <p:pic>
+        <p:nvPicPr>
+          <p:cNvPr id="6" name="Picture 5" descr="fig_scale_speedup_slide.png"/>
+          <p:cNvPicPr>
+            <a:picLocks noChangeAspect="1"/>
+          </p:cNvPicPr>
+          <p:nvPr/>
+        </p:nvPicPr>
+        <p:blipFill>
+          <a:blip r:embed="rId3"/>
+          <a:stretch>
+            <a:fillRect/>
+          </a:stretch>
+        </p:blipFill>
+        <p:spPr>
+          <a:xfrm>
+            <a:off x="457200" y="1645920"/>
+            <a:ext cx="5760720" cy="4470723"/>
+          </a:xfrm>
+          <a:prstGeom prst="rect">
+            <a:avLst/>
+          </a:prstGeom>
+        </p:spPr>
+      </p:pic>
+      <p:sp>
+        <p:nvSpPr>
+          <p:cNvPr id="7" name="TextBox 6"/>
+          <p:cNvSpPr txBox="1"/>
+          <p:nvPr/>
+        </p:nvSpPr>
+        <p:spPr>
+          <a:xfrm>
+            <a:off x="6583680" y="1737360"/>
+            <a:ext cx="3291840" cy="685800"/>
+          </a:xfrm>
+          <a:prstGeom prst="rect">
+            <a:avLst/>
+          </a:prstGeom>
+          <a:noFill/>
+        </p:spPr>
+        <p:txBody>
+          <a:bodyPr wrap="square" anchor="t" lIns="45720" rIns="45720" tIns="27432" bIns="27432">
+            <a:spAutoFit/>
+          </a:bodyPr>
+          <a:lstStyle/>
+          <a:p>
+            <a:pPr algn="l">
+              <a:lnSpc>
+                <a:spcPct val="110000"/>
+              </a:lnSpc>
+            </a:pPr>
+            <a:r>
+              <a:rPr sz="3600" b="1" i="0">
+                <a:solidFill>
+                  <a:srgbClr val="144FB0"/>
+                </a:solidFill>
+                <a:latin typeface="Helvetica"/>
+              </a:rPr>
+              <a:t>3 ms · 23 ms</a:t>
+            </a:r>
+          </a:p>
+        </p:txBody>
+      </p:sp>
+      <p:sp>
+        <p:nvSpPr>
+          <p:cNvPr id="8" name="TextBox 7"/>
+          <p:cNvSpPr txBox="1"/>
+          <p:nvPr/>
+        </p:nvSpPr>
+        <p:spPr>
+          <a:xfrm>
+            <a:off x="6583680" y="2395728"/>
+            <a:ext cx="3291840" cy="731520"/>
+          </a:xfrm>
+          <a:prstGeom prst="rect">
+            <a:avLst/>
+          </a:prstGeom>
+          <a:noFill/>
+        </p:spPr>
+        <p:txBody>
+          <a:bodyPr wrap="square" anchor="t" lIns="45720" rIns="45720" tIns="27432" bIns="27432">
+            <a:spAutoFit/>
+          </a:bodyPr>
+          <a:lstStyle/>
+          <a:p>
+            <a:pPr algn="l">
+              <a:lnSpc>
+                <a:spcPct val="110000"/>
+              </a:lnSpc>
+            </a:pPr>
+            <a:r>
+              <a:rPr sz="2000" b="0" i="0">
+                <a:solidFill>
+                  <a:srgbClr val="5B6B82"/>
+                </a:solidFill>
+                <a:latin typeface="Helvetica"/>
+              </a:rPr>
+              <a:t>P50 · P95 với REPL, nguội 63–107 s</a:t>
+            </a:r>
+          </a:p>
+        </p:txBody>
+      </p:sp>
+      <p:sp>
+        <p:nvSpPr>
+          <p:cNvPr id="9" name="TextBox 8"/>
+          <p:cNvSpPr txBox="1"/>
+          <p:nvPr/>
+        </p:nvSpPr>
+        <p:spPr>
+          <a:xfrm>
+            <a:off x="6583680" y="3200400"/>
+            <a:ext cx="3291840" cy="685800"/>
+          </a:xfrm>
+          <a:prstGeom prst="rect">
+            <a:avLst/>
+          </a:prstGeom>
+          <a:noFill/>
+        </p:spPr>
+        <p:txBody>
+          <a:bodyPr wrap="square" anchor="t" lIns="45720" rIns="45720" tIns="27432" bIns="27432">
+            <a:spAutoFit/>
+          </a:bodyPr>
+          <a:lstStyle/>
+          <a:p>
+            <a:pPr algn="l">
+              <a:lnSpc>
+                <a:spcPct val="110000"/>
+              </a:lnSpc>
+            </a:pPr>
+            <a:r>
+              <a:rPr sz="3600" b="1" i="0">
+                <a:solidFill>
+                  <a:srgbClr val="1E6FE8"/>
+                </a:solidFill>
+                <a:latin typeface="Helvetica"/>
+              </a:rPr>
+              <a:t>1,52 → 2,86</a:t>
+            </a:r>
+          </a:p>
+        </p:txBody>
+      </p:sp>
+      <p:sp>
+        <p:nvSpPr>
+          <p:cNvPr id="10" name="TextBox 9"/>
+          <p:cNvSpPr txBox="1"/>
+          <p:nvPr/>
+        </p:nvSpPr>
+        <p:spPr>
+          <a:xfrm>
+            <a:off x="6583680" y="3858768"/>
+            <a:ext cx="3291840" cy="731520"/>
+          </a:xfrm>
+          <a:prstGeom prst="rect">
+            <a:avLst/>
+          </a:prstGeom>
+          <a:noFill/>
+        </p:spPr>
+        <p:txBody>
+          <a:bodyPr wrap="square" anchor="t" lIns="45720" rIns="45720" tIns="27432" bIns="27432">
+            <a:spAutoFit/>
+          </a:bodyPr>
+          <a:lstStyle/>
+          <a:p>
+            <a:pPr algn="l">
+              <a:lnSpc>
+                <a:spcPct val="110000"/>
+              </a:lnSpc>
+            </a:pPr>
+            <a:r>
+              <a:rPr sz="2000" b="0" i="0">
+                <a:solidFill>
+                  <a:srgbClr val="5B6B82"/>
+                </a:solidFill>
+                <a:latin typeface="Helvetica"/>
+              </a:rPr>
+              <a:t>mẫu/s ở 10K, từ 1 lên 4 worker</a:t>
+            </a:r>
+          </a:p>
+        </p:txBody>
+      </p:sp>
+      <p:sp>
+        <p:nvSpPr>
+          <p:cNvPr id="11" name="TextBox 10"/>
+          <p:cNvSpPr txBox="1"/>
+          <p:nvPr/>
+        </p:nvSpPr>
+        <p:spPr>
+          <a:xfrm>
+            <a:off x="6583680" y="4663440"/>
+            <a:ext cx="3291840" cy="685800"/>
+          </a:xfrm>
+          <a:prstGeom prst="rect">
+            <a:avLst/>
+          </a:prstGeom>
+          <a:noFill/>
+        </p:spPr>
+        <p:txBody>
+          <a:bodyPr wrap="square" anchor="t" lIns="45720" rIns="45720" tIns="27432" bIns="27432">
+            <a:spAutoFit/>
+          </a:bodyPr>
+          <a:lstStyle/>
+          <a:p>
+            <a:pPr algn="l">
+              <a:lnSpc>
+                <a:spcPct val="110000"/>
+              </a:lnSpc>
+            </a:pPr>
+            <a:r>
+              <a:rPr sz="3600" b="1" i="0">
+                <a:solidFill>
+                  <a:srgbClr val="144FB0"/>
+                </a:solidFill>
+                <a:latin typeface="Helvetica"/>
+              </a:rPr>
+              <a:t>3,1 → 6,5 s</a:t>
+            </a:r>
+          </a:p>
+        </p:txBody>
+      </p:sp>
+      <p:sp>
+        <p:nvSpPr>
+          <p:cNvPr id="12" name="TextBox 11"/>
+          <p:cNvSpPr txBox="1"/>
+          <p:nvPr/>
+        </p:nvSpPr>
+        <p:spPr>
+          <a:xfrm>
+            <a:off x="6583680" y="5321807"/>
+            <a:ext cx="3291840" cy="731520"/>
+          </a:xfrm>
+          <a:prstGeom prst="rect">
+            <a:avLst/>
+          </a:prstGeom>
+          <a:noFill/>
+        </p:spPr>
+        <p:txBody>
+          <a:bodyPr wrap="square" anchor="t" lIns="45720" rIns="45720" tIns="27432" bIns="27432">
+            <a:spAutoFit/>
+          </a:bodyPr>
+          <a:lstStyle/>
+          <a:p>
+            <a:pPr algn="l">
+              <a:lnSpc>
+                <a:spcPct val="110000"/>
+              </a:lnSpc>
+            </a:pPr>
+            <a:r>
+              <a:rPr sz="2000" b="0" i="0">
+                <a:solidFill>
+                  <a:srgbClr val="5B6B82"/>
+                </a:solidFill>
+                <a:latin typeface="Helvetica"/>
+              </a:rPr>
+              <a:t>P95 phục vụ ở 10K, 1 lên 4 worker</a:t>
+            </a:r>
+          </a:p>
+        </p:txBody>
+      </p:sp>
+    </p:spTree>
+  </p:cSld>
+  <p:clrMapOvr>
+    <a:masterClrMapping/>
+  </p:clrMapOvr>
+  <mc:AlternateContent xmlns:mc="http://schemas.openxmlformats.org/markup-compatibility/2006">
+    <mc:Choice xmlns:p159="http://schemas.microsoft.com/office/powerpoint/2015/09/main" xmlns:p14="http://schemas.microsoft.com/office/powerpoint/2010/main" Requires="p159">
+      <p:transition spd="slow" p14:dur="1200">
+        <p159:morph option="byObject"/>
+      </p:transition>
+    </mc:Choice>
+    <mc:Fallback>
+      <p:transition spd="slow">
+        <p:fade/>
+      </p:transition>
+    </mc:Fallback>
+  </mc:AlternateContent>
+</p:sld>
+</file>
+
+<file path=ppt/slides/slide12.xml><?xml version="1.0" encoding="utf-8"?>
+<p:sld xmlns:a="http://schemas.openxmlformats.org/drawingml/2006/main" xmlns:p="http://schemas.openxmlformats.org/presentationml/2006/main" xmlns:r="http://schemas.openxmlformats.org/officeDocument/2006/relationships">
+  <p:cSld>
+    <p:bg>
+      <p:bgPr>
+        <a:solidFill>
+          <a:srgbClr val="FFFFFF"/>
+        </a:solidFill>
+        <a:effectLst/>
+      </p:bgPr>
+    </p:bg>
+    <p:spTree>
+      <p:nvGrpSpPr>
+        <p:cNvPr id="1" name=""/>
+        <p:cNvGrpSpPr/>
+        <p:nvPr/>
+      </p:nvGrpSpPr>
+      <p:grpSpPr/>
+      <p:sp>
+        <p:nvSpPr>
+          <p:cNvPr id="2" name="!!orb"/>
+          <p:cNvSpPr/>
+          <p:nvPr/>
+        </p:nvSpPr>
+        <p:spPr>
+          <a:xfrm>
+            <a:off x="-1828800" y="4114800"/>
+            <a:ext cx="3840480" cy="3840480"/>
+          </a:xfrm>
+          <a:prstGeom prst="ellipse">
+            <a:avLst/>
+          </a:prstGeom>
+          <a:solidFill>
+            <a:srgbClr val="EAF2FF"/>
+          </a:solidFill>
+          <a:ln>
+            <a:noFill/>
+          </a:ln>
+          <a:effectLst/>
+        </p:spPr>
+        <p:style>
+          <a:lnRef idx="1">
+            <a:schemeClr val="accent1"/>
+          </a:lnRef>
+          <a:fillRef idx="3">
+            <a:schemeClr val="accent1"/>
+          </a:fillRef>
+          <a:effectRef idx="2">
+            <a:schemeClr val="accent1"/>
+          </a:effectRef>
+          <a:fontRef idx="minor">
+            <a:schemeClr val="lt1"/>
+          </a:fontRef>
+        </p:style>
+        <p:txBody>
+          <a:bodyPr rtlCol="0" anchor="ctr"/>
+          <a:lstStyle/>
+          <a:p>
+            <a:pPr algn="ctr"/>
+          </a:p>
+        </p:txBody>
+      </p:sp>
+      <p:sp>
+        <p:nvSpPr>
+          <p:cNvPr id="3" name="!!dot"/>
+          <p:cNvSpPr/>
+          <p:nvPr/>
+        </p:nvSpPr>
+        <p:spPr>
+          <a:xfrm>
+            <a:off x="54864" y="6035040"/>
+            <a:ext cx="411480" cy="411480"/>
+          </a:xfrm>
+          <a:prstGeom prst="ellipse">
+            <a:avLst/>
+          </a:prstGeom>
+          <a:solidFill>
+            <a:srgbClr val="1E6FE8"/>
+          </a:solidFill>
+          <a:ln>
+            <a:noFill/>
+          </a:ln>
+          <a:effectLst/>
+        </p:spPr>
+        <p:style>
+          <a:lnRef idx="1">
+            <a:schemeClr val="accent1"/>
+          </a:lnRef>
+          <a:fillRef idx="3">
+            <a:schemeClr val="accent1"/>
+          </a:fillRef>
+          <a:effectRef idx="2">
+            <a:schemeClr val="accent1"/>
+          </a:effectRef>
+          <a:fontRef idx="minor">
+            <a:schemeClr val="lt1"/>
+          </a:fontRef>
+        </p:style>
+        <p:txBody>
+          <a:bodyPr rtlCol="0" anchor="ctr"/>
+          <a:lstStyle/>
+          <a:p>
+            <a:pPr algn="ctr"/>
+          </a:p>
+        </p:txBody>
+      </p:sp>
+      <p:sp>
+        <p:nvSpPr>
+          <p:cNvPr id="4" name="!!title"/>
+          <p:cNvSpPr txBox="1"/>
+          <p:nvPr/>
+        </p:nvSpPr>
+        <p:spPr>
+          <a:xfrm>
+            <a:off x="548640" y="347472"/>
+            <a:ext cx="10424160" cy="1143000"/>
+          </a:xfrm>
+          <a:prstGeom prst="rect">
+            <a:avLst/>
+          </a:prstGeom>
+          <a:noFill/>
+        </p:spPr>
+        <p:txBody>
+          <a:bodyPr wrap="square" anchor="ctr" lIns="45720" rIns="45720" tIns="27432" bIns="27432">
+            <a:spAutoFit/>
+          </a:bodyPr>
+          <a:lstStyle/>
+          <a:p>
+            <a:pPr algn="l">
+              <a:lnSpc>
+                <a:spcPct val="110000"/>
+              </a:lnSpc>
+            </a:pPr>
+            <a:r>
+              <a:rPr sz="3200" b="1" i="0">
+                <a:solidFill>
+                  <a:srgbClr val="0F1C3F"/>
+                </a:solidFill>
+                <a:latin typeface="Helvetica"/>
+              </a:rPr>
+              <a:t>Phân tích: luật đúng gần hoàn hảo, luật sai kéo chiến lược lai xuống</a:t>
+            </a:r>
+          </a:p>
+        </p:txBody>
+      </p:sp>
+      <p:sp>
+        <p:nvSpPr>
+          <p:cNvPr id="5" name="!!num"/>
+          <p:cNvSpPr txBox="1"/>
+          <p:nvPr/>
+        </p:nvSpPr>
+        <p:spPr>
+          <a:xfrm>
+            <a:off x="10881360" y="6236208"/>
+            <a:ext cx="914400" cy="457200"/>
+          </a:xfrm>
+          <a:prstGeom prst="rect">
+            <a:avLst/>
+          </a:prstGeom>
+          <a:noFill/>
+        </p:spPr>
+        <p:txBody>
+          <a:bodyPr wrap="square" anchor="t" lIns="45720" rIns="45720" tIns="27432" bIns="27432">
+            <a:spAutoFit/>
+          </a:bodyPr>
+          <a:lstStyle/>
+          <a:p>
+            <a:pPr algn="r">
+              <a:lnSpc>
+                <a:spcPct val="110000"/>
+              </a:lnSpc>
+            </a:pPr>
+            <a:r>
+              <a:rPr sz="2000" b="0" i="0">
+                <a:solidFill>
+                  <a:srgbClr val="5B6B82"/>
+                </a:solidFill>
+                <a:latin typeface="Helvetica"/>
+              </a:rPr>
+              <a:t>12</a:t>
             </a:r>
           </a:p>
         </p:txBody>
@@ -5715,7 +6710,7 @@
 </p:sld>
 </file>
 
-<file path=ppt/slides/slide11.xml><?xml version="1.0" encoding="utf-8"?>
+<file path=ppt/slides/slide13.xml><?xml version="1.0" encoding="utf-8"?>
 <p:sld xmlns:a="http://schemas.openxmlformats.org/drawingml/2006/main" xmlns:p="http://schemas.openxmlformats.org/presentationml/2006/main" xmlns:r="http://schemas.openxmlformats.org/officeDocument/2006/relationships">
   <p:cSld>
     <p:bg>
@@ -5741,8 +6736,8 @@
         </p:nvSpPr>
         <p:spPr>
           <a:xfrm>
-            <a:off x="10058400" y="-2103120"/>
-            <a:ext cx="4023360" cy="4023360"/>
+            <a:off x="9966960" y="4389120"/>
+            <a:ext cx="3566160" cy="3566160"/>
           </a:xfrm>
           <a:prstGeom prst="ellipse">
             <a:avLst/>
@@ -5785,7 +6780,7 @@
         </p:nvSpPr>
         <p:spPr>
           <a:xfrm>
-            <a:off x="11247120" y="502920"/>
+            <a:off x="11704320" y="3657600"/>
             <a:ext cx="411480" cy="411480"/>
           </a:xfrm>
           <a:prstGeom prst="ellipse">
@@ -5894,7 +6889,7 @@
                 </a:solidFill>
                 <a:latin typeface="Helvetica"/>
               </a:rPr>
-              <a:t>11</a:t>
+              <a:t>13</a:t>
             </a:r>
           </a:p>
         </p:txBody>
@@ -6309,7 +7304,7 @@
 </p:sld>
 </file>
 
-<file path=ppt/slides/slide12.xml><?xml version="1.0" encoding="utf-8"?>
+<file path=ppt/slides/slide14.xml><?xml version="1.0" encoding="utf-8"?>
 <p:sld xmlns:a="http://schemas.openxmlformats.org/drawingml/2006/main" xmlns:p="http://schemas.openxmlformats.org/presentationml/2006/main" xmlns:r="http://schemas.openxmlformats.org/officeDocument/2006/relationships">
   <p:cSld>
     <p:bg>
@@ -6335,8 +7330,8 @@
         </p:nvSpPr>
         <p:spPr>
           <a:xfrm>
-            <a:off x="-1828800" y="4114800"/>
-            <a:ext cx="3840480" cy="3840480"/>
+            <a:off x="10241280" y="-2194560"/>
+            <a:ext cx="4023360" cy="4023360"/>
           </a:xfrm>
           <a:prstGeom prst="ellipse">
             <a:avLst/>
@@ -6379,7 +7374,7 @@
         </p:nvSpPr>
         <p:spPr>
           <a:xfrm>
-            <a:off x="54864" y="6035040"/>
+            <a:off x="11247120" y="502920"/>
             <a:ext cx="411480" cy="411480"/>
           </a:xfrm>
           <a:prstGeom prst="ellipse">
@@ -6488,7 +7483,7 @@
                 </a:solidFill>
                 <a:latin typeface="Helvetica"/>
               </a:rPr>
-              <a:t>12</a:t>
+              <a:t>14</a:t>
             </a:r>
           </a:p>
         </p:txBody>
@@ -7053,7 +8048,7 @@
 </p:sld>
 </file>
 
-<file path=ppt/slides/slide13.xml><?xml version="1.0" encoding="utf-8"?>
+<file path=ppt/slides/slide15.xml><?xml version="1.0" encoding="utf-8"?>
 <p:sld xmlns:a="http://schemas.openxmlformats.org/drawingml/2006/main" xmlns:p="http://schemas.openxmlformats.org/presentationml/2006/main" xmlns:r="http://schemas.openxmlformats.org/officeDocument/2006/relationships">
   <p:cSld>
     <p:bg>
@@ -7079,8 +8074,8 @@
         </p:nvSpPr>
         <p:spPr>
           <a:xfrm>
-            <a:off x="9966960" y="4389120"/>
-            <a:ext cx="3566160" cy="3566160"/>
+            <a:off x="-1737360" y="-2011680"/>
+            <a:ext cx="3657600" cy="3657600"/>
           </a:xfrm>
           <a:prstGeom prst="ellipse">
             <a:avLst/>
@@ -7123,7 +8118,7 @@
         </p:nvSpPr>
         <p:spPr>
           <a:xfrm>
-            <a:off x="11704320" y="3657600"/>
+            <a:off x="54864" y="3291840"/>
             <a:ext cx="411480" cy="411480"/>
           </a:xfrm>
           <a:prstGeom prst="ellipse">
@@ -7232,7 +8227,7 @@
                 </a:solidFill>
                 <a:latin typeface="Helvetica"/>
               </a:rPr>
-              <a:t>13</a:t>
+              <a:t>15</a:t>
             </a:r>
           </a:p>
         </p:txBody>
@@ -7619,7 +8614,7 @@
 </p:sld>
 </file>
 
-<file path=ppt/slides/slide14.xml><?xml version="1.0" encoding="utf-8"?>
+<file path=ppt/slides/slide16.xml><?xml version="1.0" encoding="utf-8"?>
 <p:sld xmlns:a="http://schemas.openxmlformats.org/drawingml/2006/main" xmlns:p="http://schemas.openxmlformats.org/presentationml/2006/main" xmlns:r="http://schemas.openxmlformats.org/officeDocument/2006/relationships">
   <p:cSld>
     <p:bg>
@@ -7645,8 +8640,8 @@
         </p:nvSpPr>
         <p:spPr>
           <a:xfrm>
-            <a:off x="10241280" y="-2194560"/>
-            <a:ext cx="4023360" cy="4023360"/>
+            <a:off x="9875520" y="4297680"/>
+            <a:ext cx="3657600" cy="3657600"/>
           </a:xfrm>
           <a:prstGeom prst="ellipse">
             <a:avLst/>
@@ -7689,7 +8684,7 @@
         </p:nvSpPr>
         <p:spPr>
           <a:xfrm>
-            <a:off x="11247120" y="502920"/>
+            <a:off x="11704320" y="3474720"/>
             <a:ext cx="411480" cy="411480"/>
           </a:xfrm>
           <a:prstGeom prst="ellipse">
@@ -7759,7 +8754,7 @@
                 </a:solidFill>
                 <a:latin typeface="Helvetica"/>
               </a:rPr>
-              <a:t>Phụ lục P1 · RQ2: thử 3 lần đạt 65,1%, gấp đôi baseline</a:t>
+              <a:t>Phụ lục P1 · Ablation: biên dịch và thành công đã kiểm toán</a:t>
             </a:r>
           </a:p>
         </p:txBody>
@@ -7798,7 +8793,7 @@
                 </a:solidFill>
                 <a:latin typeface="Helvetica"/>
               </a:rPr>
-              <a:t>14</a:t>
+              <a:t>16</a:t>
             </a:r>
           </a:p>
         </p:txBody>
@@ -7847,7 +8842,7 @@
 </p:sld>
 </file>
 
-<file path=ppt/slides/slide15.xml><?xml version="1.0" encoding="utf-8"?>
+<file path=ppt/slides/slide17.xml><?xml version="1.0" encoding="utf-8"?>
 <p:sld xmlns:a="http://schemas.openxmlformats.org/drawingml/2006/main" xmlns:p="http://schemas.openxmlformats.org/presentationml/2006/main" xmlns:r="http://schemas.openxmlformats.org/officeDocument/2006/relationships">
   <p:cSld>
     <p:bg>
@@ -7873,8 +8868,8 @@
         </p:nvSpPr>
         <p:spPr>
           <a:xfrm>
-            <a:off x="-1737360" y="-2011680"/>
-            <a:ext cx="3657600" cy="3657600"/>
+            <a:off x="10058400" y="-2103120"/>
+            <a:ext cx="4023360" cy="4023360"/>
           </a:xfrm>
           <a:prstGeom prst="ellipse">
             <a:avLst/>
@@ -7917,7 +8912,7 @@
         </p:nvSpPr>
         <p:spPr>
           <a:xfrm>
-            <a:off x="54864" y="3291840"/>
+            <a:off x="11247120" y="502920"/>
             <a:ext cx="411480" cy="411480"/>
           </a:xfrm>
           <a:prstGeom prst="ellipse">
@@ -7987,7 +8982,7 @@
                 </a:solidFill>
                 <a:latin typeface="Helvetica"/>
               </a:rPr>
-              <a:t>Phụ lục P2 · Chẩn đoán nằm trên biên Pareto chi phí và chất lượng</a:t>
+              <a:t>Phụ lục P2 · Độ trễ phục vụ P50 và P95 ở 3 mức dữ liệu</a:t>
             </a:r>
           </a:p>
         </p:txBody>
@@ -8026,14 +9021,14 @@
                 </a:solidFill>
                 <a:latin typeface="Helvetica"/>
               </a:rPr>
-              <a:t>15</a:t>
+              <a:t>17</a:t>
             </a:r>
           </a:p>
         </p:txBody>
       </p:sp>
       <p:pic>
         <p:nvPicPr>
-          <p:cNvPr id="6" name="Picture 5" descr="fig_cost_quality_slide.png"/>
+          <p:cNvPr id="6" name="Picture 5" descr="fig_scale_latency_slide.png"/>
           <p:cNvPicPr>
             <a:picLocks noChangeAspect="1"/>
           </p:cNvPicPr>
@@ -8047,680 +9042,14 @@
         </p:blipFill>
         <p:spPr>
           <a:xfrm>
-            <a:off x="548640" y="1600200"/>
-            <a:ext cx="8349431" cy="4800600"/>
+            <a:off x="1280160" y="1600200"/>
+            <a:ext cx="9609116" cy="4754880"/>
           </a:xfrm>
           <a:prstGeom prst="rect">
             <a:avLst/>
           </a:prstGeom>
         </p:spPr>
       </p:pic>
-      <p:sp>
-        <p:nvSpPr>
-          <p:cNvPr id="7" name="Rounded Rectangle 6"/>
-          <p:cNvSpPr/>
-          <p:nvPr/>
-        </p:nvSpPr>
-        <p:spPr>
-          <a:xfrm>
-            <a:off x="9144000" y="1737360"/>
-            <a:ext cx="2468880" cy="4206240"/>
-          </a:xfrm>
-          <a:prstGeom prst="roundRect">
-            <a:avLst>
-              <a:gd name="adj" fmla="val 8000"/>
-            </a:avLst>
-          </a:prstGeom>
-          <a:solidFill>
-            <a:srgbClr val="D6E6FF"/>
-          </a:solidFill>
-          <a:ln>
-            <a:noFill/>
-          </a:ln>
-          <a:effectLst/>
-        </p:spPr>
-        <p:style>
-          <a:lnRef idx="1">
-            <a:schemeClr val="accent1"/>
-          </a:lnRef>
-          <a:fillRef idx="3">
-            <a:schemeClr val="accent1"/>
-          </a:fillRef>
-          <a:effectRef idx="2">
-            <a:schemeClr val="accent1"/>
-          </a:effectRef>
-          <a:fontRef idx="minor">
-            <a:schemeClr val="lt1"/>
-          </a:fontRef>
-        </p:style>
-        <p:txBody>
-          <a:bodyPr rtlCol="0" anchor="ctr"/>
-          <a:lstStyle/>
-          <a:p>
-            <a:pPr algn="ctr"/>
-          </a:p>
-        </p:txBody>
-      </p:sp>
-      <p:sp>
-        <p:nvSpPr>
-          <p:cNvPr id="8" name="TextBox 7"/>
-          <p:cNvSpPr txBox="1"/>
-          <p:nvPr/>
-        </p:nvSpPr>
-        <p:spPr>
-          <a:xfrm>
-            <a:off x="9372600" y="1901952"/>
-            <a:ext cx="2011680" cy="502920"/>
-          </a:xfrm>
-          <a:prstGeom prst="rect">
-            <a:avLst/>
-          </a:prstGeom>
-          <a:noFill/>
-        </p:spPr>
-        <p:txBody>
-          <a:bodyPr wrap="square" anchor="t" lIns="45720" rIns="45720" tIns="27432" bIns="27432">
-            <a:spAutoFit/>
-          </a:bodyPr>
-          <a:lstStyle/>
-          <a:p>
-            <a:pPr algn="l">
-              <a:lnSpc>
-                <a:spcPct val="110000"/>
-              </a:lnSpc>
-            </a:pPr>
-            <a:r>
-              <a:rPr sz="2200" b="1" i="0">
-                <a:solidFill>
-                  <a:srgbClr val="144FB0"/>
-                </a:solidFill>
-                <a:latin typeface="Helvetica"/>
-              </a:rPr>
-              <a:t>Đọc biểu đồ</a:t>
-            </a:r>
-          </a:p>
-        </p:txBody>
-      </p:sp>
-      <p:sp>
-        <p:nvSpPr>
-          <p:cNvPr id="9" name="TextBox 8"/>
-          <p:cNvSpPr txBox="1"/>
-          <p:nvPr/>
-        </p:nvSpPr>
-        <p:spPr>
-          <a:xfrm>
-            <a:off x="9372600" y="2468880"/>
-            <a:ext cx="2011680" cy="3337559"/>
-          </a:xfrm>
-          <a:prstGeom prst="rect">
-            <a:avLst/>
-          </a:prstGeom>
-          <a:noFill/>
-        </p:spPr>
-        <p:txBody>
-          <a:bodyPr wrap="square">
-            <a:spAutoFit/>
-          </a:bodyPr>
-          <a:lstStyle/>
-          <a:p>
-            <a:pPr marL="292608" indent="-292608">
-              <a:lnSpc>
-                <a:spcPct val="108000"/>
-              </a:lnSpc>
-              <a:spcAft>
-                <a:spcPts val="600"/>
-              </a:spcAft>
-              <a:buClr>
-                <a:srgbClr val="1E6FE8"/>
-              </a:buClr>
-              <a:buFont typeface="Helvetica"/>
-              <a:buChar char="•"/>
-            </a:pPr>
-            <a:r>
-              <a:rPr sz="2000" b="0" i="0">
-                <a:solidFill>
-                  <a:srgbClr val="0F1C3F"/>
-                </a:solidFill>
-                <a:latin typeface="Helvetica"/>
-              </a:rPr>
-              <a:t>$0: luật 23,9%</a:t>
-            </a:r>
-          </a:p>
-          <a:p>
-            <a:pPr marL="292608" indent="-292608">
-              <a:lnSpc>
-                <a:spcPct val="108000"/>
-              </a:lnSpc>
-              <a:spcAft>
-                <a:spcPts val="600"/>
-              </a:spcAft>
-              <a:buClr>
-                <a:srgbClr val="1E6FE8"/>
-              </a:buClr>
-              <a:buFont typeface="Helvetica"/>
-              <a:buChar char="•"/>
-            </a:pPr>
-            <a:r>
-              <a:rPr sz="2000" b="0" i="0">
-                <a:solidFill>
-                  <a:srgbClr val="0F1C3F"/>
-                </a:solidFill>
-                <a:latin typeface="Helvetica"/>
-              </a:rPr>
-              <a:t>$1,13: 53,9%</a:t>
-            </a:r>
-          </a:p>
-          <a:p>
-            <a:pPr marL="292608" indent="-292608">
-              <a:lnSpc>
-                <a:spcPct val="108000"/>
-              </a:lnSpc>
-              <a:spcAft>
-                <a:spcPts val="600"/>
-              </a:spcAft>
-              <a:buClr>
-                <a:srgbClr val="1E6FE8"/>
-              </a:buClr>
-              <a:buFont typeface="Helvetica"/>
-              <a:buChar char="•"/>
-            </a:pPr>
-            <a:r>
-              <a:rPr sz="2000" b="0" i="0">
-                <a:solidFill>
-                  <a:srgbClr val="0F1C3F"/>
-                </a:solidFill>
-                <a:latin typeface="Helvetica"/>
-              </a:rPr>
-              <a:t>$2,45: 65,1%</a:t>
-            </a:r>
-          </a:p>
-          <a:p>
-            <a:pPr marL="292608" indent="-292608">
-              <a:lnSpc>
-                <a:spcPct val="108000"/>
-              </a:lnSpc>
-              <a:spcAft>
-                <a:spcPts val="600"/>
-              </a:spcAft>
-              <a:buClr>
-                <a:srgbClr val="1E6FE8"/>
-              </a:buClr>
-              <a:buFont typeface="Helvetica"/>
-              <a:buChar char="•"/>
-            </a:pPr>
-            <a:r>
-              <a:rPr sz="2000" b="0" i="0">
-                <a:solidFill>
-                  <a:srgbClr val="0F1C3F"/>
-                </a:solidFill>
-                <a:latin typeface="Helvetica"/>
-              </a:rPr>
-              <a:t>Blind $2,05: 31,7%</a:t>
-            </a:r>
-          </a:p>
-        </p:txBody>
-      </p:sp>
-    </p:spTree>
-  </p:cSld>
-  <p:clrMapOvr>
-    <a:masterClrMapping/>
-  </p:clrMapOvr>
-  <mc:AlternateContent xmlns:mc="http://schemas.openxmlformats.org/markup-compatibility/2006">
-    <mc:Choice xmlns:p159="http://schemas.microsoft.com/office/powerpoint/2015/09/main" xmlns:p14="http://schemas.microsoft.com/office/powerpoint/2010/main" Requires="p159">
-      <p:transition spd="slow" p14:dur="1200">
-        <p159:morph option="byObject"/>
-      </p:transition>
-    </mc:Choice>
-    <mc:Fallback>
-      <p:transition spd="slow">
-        <p:fade/>
-      </p:transition>
-    </mc:Fallback>
-  </mc:AlternateContent>
-</p:sld>
-</file>
-
-<file path=ppt/slides/slide16.xml><?xml version="1.0" encoding="utf-8"?>
-<p:sld xmlns:a="http://schemas.openxmlformats.org/drawingml/2006/main" xmlns:p="http://schemas.openxmlformats.org/presentationml/2006/main" xmlns:r="http://schemas.openxmlformats.org/officeDocument/2006/relationships">
-  <p:cSld>
-    <p:bg>
-      <p:bgPr>
-        <a:solidFill>
-          <a:srgbClr val="FFFFFF"/>
-        </a:solidFill>
-        <a:effectLst/>
-      </p:bgPr>
-    </p:bg>
-    <p:spTree>
-      <p:nvGrpSpPr>
-        <p:cNvPr id="1" name=""/>
-        <p:cNvGrpSpPr/>
-        <p:nvPr/>
-      </p:nvGrpSpPr>
-      <p:grpSpPr/>
-      <p:sp>
-        <p:nvSpPr>
-          <p:cNvPr id="2" name="!!orb"/>
-          <p:cNvSpPr/>
-          <p:nvPr/>
-        </p:nvSpPr>
-        <p:spPr>
-          <a:xfrm>
-            <a:off x="9875520" y="4297680"/>
-            <a:ext cx="3657600" cy="3657600"/>
-          </a:xfrm>
-          <a:prstGeom prst="ellipse">
-            <a:avLst/>
-          </a:prstGeom>
-          <a:solidFill>
-            <a:srgbClr val="EAF2FF"/>
-          </a:solidFill>
-          <a:ln>
-            <a:noFill/>
-          </a:ln>
-          <a:effectLst/>
-        </p:spPr>
-        <p:style>
-          <a:lnRef idx="1">
-            <a:schemeClr val="accent1"/>
-          </a:lnRef>
-          <a:fillRef idx="3">
-            <a:schemeClr val="accent1"/>
-          </a:fillRef>
-          <a:effectRef idx="2">
-            <a:schemeClr val="accent1"/>
-          </a:effectRef>
-          <a:fontRef idx="minor">
-            <a:schemeClr val="lt1"/>
-          </a:fontRef>
-        </p:style>
-        <p:txBody>
-          <a:bodyPr rtlCol="0" anchor="ctr"/>
-          <a:lstStyle/>
-          <a:p>
-            <a:pPr algn="ctr"/>
-          </a:p>
-        </p:txBody>
-      </p:sp>
-      <p:sp>
-        <p:nvSpPr>
-          <p:cNvPr id="3" name="!!dot"/>
-          <p:cNvSpPr/>
-          <p:nvPr/>
-        </p:nvSpPr>
-        <p:spPr>
-          <a:xfrm>
-            <a:off x="11704320" y="3474720"/>
-            <a:ext cx="411480" cy="411480"/>
-          </a:xfrm>
-          <a:prstGeom prst="ellipse">
-            <a:avLst/>
-          </a:prstGeom>
-          <a:solidFill>
-            <a:srgbClr val="1E6FE8"/>
-          </a:solidFill>
-          <a:ln>
-            <a:noFill/>
-          </a:ln>
-          <a:effectLst/>
-        </p:spPr>
-        <p:style>
-          <a:lnRef idx="1">
-            <a:schemeClr val="accent1"/>
-          </a:lnRef>
-          <a:fillRef idx="3">
-            <a:schemeClr val="accent1"/>
-          </a:fillRef>
-          <a:effectRef idx="2">
-            <a:schemeClr val="accent1"/>
-          </a:effectRef>
-          <a:fontRef idx="minor">
-            <a:schemeClr val="lt1"/>
-          </a:fontRef>
-        </p:style>
-        <p:txBody>
-          <a:bodyPr rtlCol="0" anchor="ctr"/>
-          <a:lstStyle/>
-          <a:p>
-            <a:pPr algn="ctr"/>
-          </a:p>
-        </p:txBody>
-      </p:sp>
-      <p:sp>
-        <p:nvSpPr>
-          <p:cNvPr id="4" name="!!title"/>
-          <p:cNvSpPr txBox="1"/>
-          <p:nvPr/>
-        </p:nvSpPr>
-        <p:spPr>
-          <a:xfrm>
-            <a:off x="548640" y="347472"/>
-            <a:ext cx="10424160" cy="1143000"/>
-          </a:xfrm>
-          <a:prstGeom prst="rect">
-            <a:avLst/>
-          </a:prstGeom>
-          <a:noFill/>
-        </p:spPr>
-        <p:txBody>
-          <a:bodyPr wrap="square" anchor="ctr" lIns="45720" rIns="45720" tIns="27432" bIns="27432">
-            <a:spAutoFit/>
-          </a:bodyPr>
-          <a:lstStyle/>
-          <a:p>
-            <a:pPr algn="l">
-              <a:lnSpc>
-                <a:spcPct val="110000"/>
-              </a:lnSpc>
-            </a:pPr>
-            <a:r>
-              <a:rPr sz="3200" b="1" i="0">
-                <a:solidFill>
-                  <a:srgbClr val="0F1C3F"/>
-                </a:solidFill>
-                <a:latin typeface="Helvetica"/>
-              </a:rPr>
-              <a:t>Phụ lục P3 · RQ3: REPL nhanh 3–4 bậc, 4 worker chỉ 1,88× vì nghẽn CPU</a:t>
-            </a:r>
-          </a:p>
-        </p:txBody>
-      </p:sp>
-      <p:sp>
-        <p:nvSpPr>
-          <p:cNvPr id="5" name="!!num"/>
-          <p:cNvSpPr txBox="1"/>
-          <p:nvPr/>
-        </p:nvSpPr>
-        <p:spPr>
-          <a:xfrm>
-            <a:off x="10881360" y="6236208"/>
-            <a:ext cx="914400" cy="457200"/>
-          </a:xfrm>
-          <a:prstGeom prst="rect">
-            <a:avLst/>
-          </a:prstGeom>
-          <a:noFill/>
-        </p:spPr>
-        <p:txBody>
-          <a:bodyPr wrap="square" anchor="t" lIns="45720" rIns="45720" tIns="27432" bIns="27432">
-            <a:spAutoFit/>
-          </a:bodyPr>
-          <a:lstStyle/>
-          <a:p>
-            <a:pPr algn="r">
-              <a:lnSpc>
-                <a:spcPct val="110000"/>
-              </a:lnSpc>
-            </a:pPr>
-            <a:r>
-              <a:rPr sz="2000" b="0" i="0">
-                <a:solidFill>
-                  <a:srgbClr val="5B6B82"/>
-                </a:solidFill>
-                <a:latin typeface="Helvetica"/>
-              </a:rPr>
-              <a:t>16</a:t>
-            </a:r>
-          </a:p>
-        </p:txBody>
-      </p:sp>
-      <p:pic>
-        <p:nvPicPr>
-          <p:cNvPr id="6" name="Picture 5" descr="fig_scale_speedup_slide.png"/>
-          <p:cNvPicPr>
-            <a:picLocks noChangeAspect="1"/>
-          </p:cNvPicPr>
-          <p:nvPr/>
-        </p:nvPicPr>
-        <p:blipFill>
-          <a:blip r:embed="rId3"/>
-          <a:stretch>
-            <a:fillRect/>
-          </a:stretch>
-        </p:blipFill>
-        <p:spPr>
-          <a:xfrm>
-            <a:off x="457200" y="1645920"/>
-            <a:ext cx="5760720" cy="4470723"/>
-          </a:xfrm>
-          <a:prstGeom prst="rect">
-            <a:avLst/>
-          </a:prstGeom>
-        </p:spPr>
-      </p:pic>
-      <p:sp>
-        <p:nvSpPr>
-          <p:cNvPr id="7" name="TextBox 6"/>
-          <p:cNvSpPr txBox="1"/>
-          <p:nvPr/>
-        </p:nvSpPr>
-        <p:spPr>
-          <a:xfrm>
-            <a:off x="6400800" y="1691640"/>
-            <a:ext cx="5120640" cy="868680"/>
-          </a:xfrm>
-          <a:prstGeom prst="rect">
-            <a:avLst/>
-          </a:prstGeom>
-          <a:noFill/>
-        </p:spPr>
-        <p:txBody>
-          <a:bodyPr wrap="square" anchor="t" lIns="45720" rIns="45720" tIns="27432" bIns="27432">
-            <a:spAutoFit/>
-          </a:bodyPr>
-          <a:lstStyle/>
-          <a:p>
-            <a:pPr algn="l">
-              <a:lnSpc>
-                <a:spcPct val="110000"/>
-              </a:lnSpc>
-            </a:pPr>
-            <a:r>
-              <a:rPr sz="4800" b="1" i="0">
-                <a:solidFill>
-                  <a:srgbClr val="144FB0"/>
-                </a:solidFill>
-                <a:latin typeface="Helvetica"/>
-              </a:rPr>
-              <a:t>3 ms · 23 ms</a:t>
-            </a:r>
-          </a:p>
-        </p:txBody>
-      </p:sp>
-      <p:sp>
-        <p:nvSpPr>
-          <p:cNvPr id="8" name="TextBox 7"/>
-          <p:cNvSpPr txBox="1"/>
-          <p:nvPr/>
-        </p:nvSpPr>
-        <p:spPr>
-          <a:xfrm>
-            <a:off x="6400800" y="2560320"/>
-            <a:ext cx="5120640" cy="777240"/>
-          </a:xfrm>
-          <a:prstGeom prst="rect">
-            <a:avLst/>
-          </a:prstGeom>
-          <a:noFill/>
-        </p:spPr>
-        <p:txBody>
-          <a:bodyPr wrap="square" anchor="t" lIns="45720" rIns="45720" tIns="27432" bIns="27432">
-            <a:spAutoFit/>
-          </a:bodyPr>
-          <a:lstStyle/>
-          <a:p>
-            <a:pPr algn="l">
-              <a:lnSpc>
-                <a:spcPct val="110000"/>
-              </a:lnSpc>
-            </a:pPr>
-            <a:r>
-              <a:rPr sz="2000" b="0" i="0">
-                <a:solidFill>
-                  <a:srgbClr val="5B6B82"/>
-                </a:solidFill>
-                <a:latin typeface="Helvetica"/>
-              </a:rPr>
-              <a:t>P50 · P95 với REPL, nguội 63–107 s</a:t>
-            </a:r>
-          </a:p>
-        </p:txBody>
-      </p:sp>
-      <p:sp>
-        <p:nvSpPr>
-          <p:cNvPr id="9" name="TextBox 8"/>
-          <p:cNvSpPr txBox="1"/>
-          <p:nvPr/>
-        </p:nvSpPr>
-        <p:spPr>
-          <a:xfrm>
-            <a:off x="6400800" y="3200400"/>
-            <a:ext cx="5120640" cy="868680"/>
-          </a:xfrm>
-          <a:prstGeom prst="rect">
-            <a:avLst/>
-          </a:prstGeom>
-          <a:noFill/>
-        </p:spPr>
-        <p:txBody>
-          <a:bodyPr wrap="square" anchor="t" lIns="45720" rIns="45720" tIns="27432" bIns="27432">
-            <a:spAutoFit/>
-          </a:bodyPr>
-          <a:lstStyle/>
-          <a:p>
-            <a:pPr algn="l">
-              <a:lnSpc>
-                <a:spcPct val="110000"/>
-              </a:lnSpc>
-            </a:pPr>
-            <a:r>
-              <a:rPr sz="4800" b="1" i="0">
-                <a:solidFill>
-                  <a:srgbClr val="1E6FE8"/>
-                </a:solidFill>
-                <a:latin typeface="Helvetica"/>
-              </a:rPr>
-              <a:t>1,52 → 2,86</a:t>
-            </a:r>
-          </a:p>
-        </p:txBody>
-      </p:sp>
-      <p:sp>
-        <p:nvSpPr>
-          <p:cNvPr id="10" name="TextBox 9"/>
-          <p:cNvSpPr txBox="1"/>
-          <p:nvPr/>
-        </p:nvSpPr>
-        <p:spPr>
-          <a:xfrm>
-            <a:off x="6400800" y="4069080"/>
-            <a:ext cx="5120640" cy="777240"/>
-          </a:xfrm>
-          <a:prstGeom prst="rect">
-            <a:avLst/>
-          </a:prstGeom>
-          <a:noFill/>
-        </p:spPr>
-        <p:txBody>
-          <a:bodyPr wrap="square" anchor="t" lIns="45720" rIns="45720" tIns="27432" bIns="27432">
-            <a:spAutoFit/>
-          </a:bodyPr>
-          <a:lstStyle/>
-          <a:p>
-            <a:pPr algn="l">
-              <a:lnSpc>
-                <a:spcPct val="110000"/>
-              </a:lnSpc>
-            </a:pPr>
-            <a:r>
-              <a:rPr sz="2000" b="0" i="0">
-                <a:solidFill>
-                  <a:srgbClr val="5B6B82"/>
-                </a:solidFill>
-                <a:latin typeface="Helvetica"/>
-              </a:rPr>
-              <a:t>mẫu/s ở 10K, từ 1 lên 4 worker</a:t>
-            </a:r>
-          </a:p>
-        </p:txBody>
-      </p:sp>
-      <p:sp>
-        <p:nvSpPr>
-          <p:cNvPr id="11" name="TextBox 10"/>
-          <p:cNvSpPr txBox="1"/>
-          <p:nvPr/>
-        </p:nvSpPr>
-        <p:spPr>
-          <a:xfrm>
-            <a:off x="6400800" y="4709160"/>
-            <a:ext cx="5120640" cy="868680"/>
-          </a:xfrm>
-          <a:prstGeom prst="rect">
-            <a:avLst/>
-          </a:prstGeom>
-          <a:noFill/>
-        </p:spPr>
-        <p:txBody>
-          <a:bodyPr wrap="square" anchor="t" lIns="45720" rIns="45720" tIns="27432" bIns="27432">
-            <a:spAutoFit/>
-          </a:bodyPr>
-          <a:lstStyle/>
-          <a:p>
-            <a:pPr algn="l">
-              <a:lnSpc>
-                <a:spcPct val="110000"/>
-              </a:lnSpc>
-            </a:pPr>
-            <a:r>
-              <a:rPr sz="4800" b="1" i="0">
-                <a:solidFill>
-                  <a:srgbClr val="144FB0"/>
-                </a:solidFill>
-                <a:latin typeface="Helvetica"/>
-              </a:rPr>
-              <a:t>3,1 → 6,5 s</a:t>
-            </a:r>
-          </a:p>
-        </p:txBody>
-      </p:sp>
-      <p:sp>
-        <p:nvSpPr>
-          <p:cNvPr id="12" name="TextBox 11"/>
-          <p:cNvSpPr txBox="1"/>
-          <p:nvPr/>
-        </p:nvSpPr>
-        <p:spPr>
-          <a:xfrm>
-            <a:off x="6400800" y="5577840"/>
-            <a:ext cx="5120640" cy="777240"/>
-          </a:xfrm>
-          <a:prstGeom prst="rect">
-            <a:avLst/>
-          </a:prstGeom>
-          <a:noFill/>
-        </p:spPr>
-        <p:txBody>
-          <a:bodyPr wrap="square" anchor="t" lIns="45720" rIns="45720" tIns="27432" bIns="27432">
-            <a:spAutoFit/>
-          </a:bodyPr>
-          <a:lstStyle/>
-          <a:p>
-            <a:pPr algn="l">
-              <a:lnSpc>
-                <a:spcPct val="110000"/>
-              </a:lnSpc>
-            </a:pPr>
-            <a:r>
-              <a:rPr sz="2000" b="0" i="0">
-                <a:solidFill>
-                  <a:srgbClr val="5B6B82"/>
-                </a:solidFill>
-                <a:latin typeface="Helvetica"/>
-              </a:rPr>
-              <a:t>P95 thời gian phục vụ, 1 lên 4 worker</a:t>
-            </a:r>
-          </a:p>
-        </p:txBody>
-      </p:sp>
     </p:spTree>
   </p:cSld>
   <p:clrMapOvr>
@@ -15269,7 +15598,7 @@
                 </a:solidFill>
                 <a:latin typeface="Helvetica"/>
               </a:rPr>
-              <a:t>Kết quả: chẩn đoán vừa tốt hơn vừa rẻ hơn, REPL gỡ nút thắt kiểm chứng</a:t>
+              <a:t>RQ1: thông báo lỗi tăng 22 điểm % và còn rẻ hơn 45%</a:t>
             </a:r>
           </a:p>
         </p:txBody>
@@ -15313,52 +15642,30 @@
           </a:p>
         </p:txBody>
       </p:sp>
-      <p:sp>
-        <p:nvSpPr>
-          <p:cNvPr id="6" name="Rounded Rectangle 5"/>
-          <p:cNvSpPr/>
-          <p:nvPr/>
-        </p:nvSpPr>
-        <p:spPr>
-          <a:xfrm>
-            <a:off x="548640" y="1691640"/>
-            <a:ext cx="3566160" cy="4343400"/>
-          </a:xfrm>
-          <a:prstGeom prst="roundRect">
-            <a:avLst>
-              <a:gd name="adj" fmla="val 8000"/>
-            </a:avLst>
-          </a:prstGeom>
-          <a:solidFill>
-            <a:srgbClr val="EAF2FF"/>
-          </a:solidFill>
-          <a:ln>
-            <a:noFill/>
-          </a:ln>
-          <a:effectLst/>
-        </p:spPr>
-        <p:style>
-          <a:lnRef idx="1">
-            <a:schemeClr val="accent1"/>
-          </a:lnRef>
-          <a:fillRef idx="3">
-            <a:schemeClr val="accent1"/>
-          </a:fillRef>
-          <a:effectRef idx="2">
-            <a:schemeClr val="accent1"/>
-          </a:effectRef>
-          <a:fontRef idx="minor">
-            <a:schemeClr val="lt1"/>
-          </a:fontRef>
-        </p:style>
-        <p:txBody>
-          <a:bodyPr rtlCol="0" anchor="ctr"/>
-          <a:lstStyle/>
-          <a:p>
-            <a:pPr algn="ctr"/>
-          </a:p>
-        </p:txBody>
-      </p:sp>
+      <p:pic>
+        <p:nvPicPr>
+          <p:cNvPr id="6" name="Picture 5" descr="fig_rq1_category_slide.png"/>
+          <p:cNvPicPr>
+            <a:picLocks noChangeAspect="1"/>
+          </p:cNvPicPr>
+          <p:nvPr/>
+        </p:nvPicPr>
+        <p:blipFill>
+          <a:blip r:embed="rId3"/>
+          <a:stretch>
+            <a:fillRect/>
+          </a:stretch>
+        </p:blipFill>
+        <p:spPr>
+          <a:xfrm>
+            <a:off x="457200" y="1783080"/>
+            <a:ext cx="7680960" cy="3970116"/>
+          </a:xfrm>
+          <a:prstGeom prst="rect">
+            <a:avLst/>
+          </a:prstGeom>
+        </p:spPr>
+      </p:pic>
       <p:sp>
         <p:nvSpPr>
           <p:cNvPr id="7" name="TextBox 6"/>
@@ -15367,8 +15674,8 @@
         </p:nvSpPr>
         <p:spPr>
           <a:xfrm>
-            <a:off x="777240" y="1828800"/>
-            <a:ext cx="3108960" cy="457200"/>
+            <a:off x="8412480" y="1737360"/>
+            <a:ext cx="3291840" cy="685800"/>
           </a:xfrm>
           <a:prstGeom prst="rect">
             <a:avLst/>
@@ -15387,13 +15694,13 @@
               </a:lnSpc>
             </a:pPr>
             <a:r>
-              <a:rPr sz="2200" b="1" i="0">
+              <a:rPr sz="3600" b="1" i="0">
                 <a:solidFill>
                   <a:srgbClr val="144FB0"/>
                 </a:solidFill>
                 <a:latin typeface="Helvetica"/>
               </a:rPr>
-              <a:t>RQ1 · Thông báo lỗi</a:t>
+              <a:t>53,9%</a:t>
             </a:r>
           </a:p>
         </p:txBody>
@@ -15406,8 +15713,8 @@
         </p:nvSpPr>
         <p:spPr>
           <a:xfrm>
-            <a:off x="777240" y="2331720"/>
-            <a:ext cx="3200400" cy="777240"/>
+            <a:off x="8412480" y="2395728"/>
+            <a:ext cx="3291840" cy="731520"/>
           </a:xfrm>
           <a:prstGeom prst="rect">
             <a:avLst/>
@@ -15426,13 +15733,13 @@
               </a:lnSpc>
             </a:pPr>
             <a:r>
-              <a:rPr sz="4000" b="1" i="0">
-                <a:solidFill>
-                  <a:srgbClr val="1E6FE8"/>
-                </a:solidFill>
-                <a:latin typeface="Helvetica"/>
-              </a:rPr>
-              <a:t>53,9%</a:t>
+              <a:rPr sz="2000" b="0" i="0">
+                <a:solidFill>
+                  <a:srgbClr val="5B6B82"/>
+                </a:solidFill>
+                <a:latin typeface="Helvetica"/>
+              </a:rPr>
+              <a:t>thành công k=1, baseline 31,7%</a:t>
             </a:r>
           </a:p>
         </p:txBody>
@@ -15445,8 +15752,8 @@
         </p:nvSpPr>
         <p:spPr>
           <a:xfrm>
-            <a:off x="777240" y="3108960"/>
-            <a:ext cx="3108960" cy="457200"/>
+            <a:off x="8412480" y="3200400"/>
+            <a:ext cx="3291840" cy="685800"/>
           </a:xfrm>
           <a:prstGeom prst="rect">
             <a:avLst/>
@@ -15465,13 +15772,13 @@
               </a:lnSpc>
             </a:pPr>
             <a:r>
-              <a:rPr sz="2000" b="0" i="0">
-                <a:solidFill>
-                  <a:srgbClr val="5B6B82"/>
-                </a:solidFill>
-                <a:latin typeface="Helvetica"/>
-              </a:rPr>
-              <a:t>thành công đã kiểm toán</a:t>
+              <a:rPr sz="3600" b="1" i="0">
+                <a:solidFill>
+                  <a:srgbClr val="1E6FE8"/>
+                </a:solidFill>
+                <a:latin typeface="Helvetica"/>
+              </a:rPr>
+              <a:t>$1,13</a:t>
             </a:r>
           </a:p>
         </p:txBody>
@@ -15484,125 +15791,8 @@
         </p:nvSpPr>
         <p:spPr>
           <a:xfrm>
-            <a:off x="777240" y="3794760"/>
-            <a:ext cx="3154680" cy="2194560"/>
-          </a:xfrm>
-          <a:prstGeom prst="rect">
-            <a:avLst/>
-          </a:prstGeom>
-          <a:noFill/>
-        </p:spPr>
-        <p:txBody>
-          <a:bodyPr wrap="square">
-            <a:spAutoFit/>
-          </a:bodyPr>
-          <a:lstStyle/>
-          <a:p>
-            <a:pPr marL="292608" indent="-292608">
-              <a:lnSpc>
-                <a:spcPct val="108000"/>
-              </a:lnSpc>
-              <a:spcAft>
-                <a:spcPts val="400"/>
-              </a:spcAft>
-              <a:buClr>
-                <a:srgbClr val="1E6FE8"/>
-              </a:buClr>
-              <a:buFont typeface="Helvetica"/>
-              <a:buChar char="•"/>
-            </a:pPr>
-            <a:r>
-              <a:rPr sz="2000" b="0" i="0">
-                <a:solidFill>
-                  <a:srgbClr val="0F1C3F"/>
-                </a:solidFill>
-                <a:latin typeface="Helvetica"/>
-              </a:rPr>
-              <a:t>Baseline 31,7%, cùng k=1</a:t>
-            </a:r>
-          </a:p>
-          <a:p>
-            <a:pPr marL="292608" indent="-292608">
-              <a:lnSpc>
-                <a:spcPct val="108000"/>
-              </a:lnSpc>
-              <a:spcAft>
-                <a:spcPts val="400"/>
-              </a:spcAft>
-              <a:buClr>
-                <a:srgbClr val="1E6FE8"/>
-              </a:buClr>
-              <a:buFont typeface="Helvetica"/>
-              <a:buChar char="•"/>
-            </a:pPr>
-            <a:r>
-              <a:rPr sz="2000" b="0" i="0">
-                <a:solidFill>
-                  <a:srgbClr val="0F1C3F"/>
-                </a:solidFill>
-                <a:latin typeface="Helvetica"/>
-              </a:rPr>
-              <a:t>Rẻ hơn 45%: $1,13 / 1K mẫu</a:t>
-            </a:r>
-          </a:p>
-        </p:txBody>
-      </p:sp>
-      <p:sp>
-        <p:nvSpPr>
-          <p:cNvPr id="11" name="Rounded Rectangle 10"/>
-          <p:cNvSpPr/>
-          <p:nvPr/>
-        </p:nvSpPr>
-        <p:spPr>
-          <a:xfrm>
-            <a:off x="4297679" y="1691640"/>
-            <a:ext cx="3566160" cy="4343400"/>
-          </a:xfrm>
-          <a:prstGeom prst="roundRect">
-            <a:avLst>
-              <a:gd name="adj" fmla="val 8000"/>
-            </a:avLst>
-          </a:prstGeom>
-          <a:solidFill>
-            <a:srgbClr val="D6E6FF"/>
-          </a:solidFill>
-          <a:ln>
-            <a:noFill/>
-          </a:ln>
-          <a:effectLst/>
-        </p:spPr>
-        <p:style>
-          <a:lnRef idx="1">
-            <a:schemeClr val="accent1"/>
-          </a:lnRef>
-          <a:fillRef idx="3">
-            <a:schemeClr val="accent1"/>
-          </a:fillRef>
-          <a:effectRef idx="2">
-            <a:schemeClr val="accent1"/>
-          </a:effectRef>
-          <a:fontRef idx="minor">
-            <a:schemeClr val="lt1"/>
-          </a:fontRef>
-        </p:style>
-        <p:txBody>
-          <a:bodyPr rtlCol="0" anchor="ctr"/>
-          <a:lstStyle/>
-          <a:p>
-            <a:pPr algn="ctr"/>
-          </a:p>
-        </p:txBody>
-      </p:sp>
-      <p:sp>
-        <p:nvSpPr>
-          <p:cNvPr id="12" name="TextBox 11"/>
-          <p:cNvSpPr txBox="1"/>
-          <p:nvPr/>
-        </p:nvSpPr>
-        <p:spPr>
-          <a:xfrm>
-            <a:off x="4526279" y="1828800"/>
-            <a:ext cx="3108960" cy="457200"/>
+            <a:off x="8412480" y="3858768"/>
+            <a:ext cx="3291840" cy="731520"/>
           </a:xfrm>
           <a:prstGeom prst="rect">
             <a:avLst/>
@@ -15621,27 +15811,27 @@
               </a:lnSpc>
             </a:pPr>
             <a:r>
-              <a:rPr sz="2200" b="1" i="0">
-                <a:solidFill>
-                  <a:srgbClr val="144FB0"/>
-                </a:solidFill>
-                <a:latin typeface="Helvetica"/>
-              </a:rPr>
-              <a:t>RQ2 · Chiến lược</a:t>
-            </a:r>
-          </a:p>
-        </p:txBody>
-      </p:sp>
-      <p:sp>
-        <p:nvSpPr>
-          <p:cNvPr id="13" name="TextBox 12"/>
+              <a:rPr sz="2000" b="0" i="0">
+                <a:solidFill>
+                  <a:srgbClr val="5B6B82"/>
+                </a:solidFill>
+                <a:latin typeface="Helvetica"/>
+              </a:rPr>
+              <a:t>mỗi 1.000 mẫu, baseline $2,05</a:t>
+            </a:r>
+          </a:p>
+        </p:txBody>
+      </p:sp>
+      <p:sp>
+        <p:nvSpPr>
+          <p:cNvPr id="11" name="TextBox 10"/>
           <p:cNvSpPr txBox="1"/>
           <p:nvPr/>
         </p:nvSpPr>
         <p:spPr>
           <a:xfrm>
-            <a:off x="4526279" y="2331720"/>
-            <a:ext cx="3200400" cy="777240"/>
+            <a:off x="8412480" y="4709160"/>
+            <a:ext cx="3200400" cy="1280160"/>
           </a:xfrm>
           <a:prstGeom prst="rect">
             <a:avLst/>
@@ -15660,444 +15850,13 @@
               </a:lnSpc>
             </a:pPr>
             <a:r>
-              <a:rPr sz="4000" b="1" i="0">
-                <a:solidFill>
-                  <a:srgbClr val="1E6FE8"/>
-                </a:solidFill>
-                <a:latin typeface="Helvetica"/>
-              </a:rPr>
-              <a:t>65,1%</a:t>
-            </a:r>
-          </a:p>
-        </p:txBody>
-      </p:sp>
-      <p:sp>
-        <p:nvSpPr>
-          <p:cNvPr id="14" name="TextBox 13"/>
-          <p:cNvSpPr txBox="1"/>
-          <p:nvPr/>
-        </p:nvSpPr>
-        <p:spPr>
-          <a:xfrm>
-            <a:off x="4526279" y="3108960"/>
-            <a:ext cx="3108960" cy="457200"/>
-          </a:xfrm>
-          <a:prstGeom prst="rect">
-            <a:avLst/>
-          </a:prstGeom>
-          <a:noFill/>
-        </p:spPr>
-        <p:txBody>
-          <a:bodyPr wrap="square" anchor="t" lIns="45720" rIns="45720" tIns="27432" bIns="27432">
-            <a:spAutoFit/>
-          </a:bodyPr>
-          <a:lstStyle/>
-          <a:p>
-            <a:pPr algn="l">
-              <a:lnSpc>
-                <a:spcPct val="110000"/>
-              </a:lnSpc>
-            </a:pPr>
-            <a:r>
               <a:rPr sz="2000" b="0" i="0">
                 <a:solidFill>
                   <a:srgbClr val="5B6B82"/>
                 </a:solidFill>
                 <a:latin typeface="Helvetica"/>
               </a:rPr>
-              <a:t>LLM + chẩn đoán, k=3</a:t>
-            </a:r>
-          </a:p>
-        </p:txBody>
-      </p:sp>
-      <p:sp>
-        <p:nvSpPr>
-          <p:cNvPr id="15" name="TextBox 14"/>
-          <p:cNvSpPr txBox="1"/>
-          <p:nvPr/>
-        </p:nvSpPr>
-        <p:spPr>
-          <a:xfrm>
-            <a:off x="4526279" y="3794760"/>
-            <a:ext cx="3154680" cy="2194560"/>
-          </a:xfrm>
-          <a:prstGeom prst="rect">
-            <a:avLst/>
-          </a:prstGeom>
-          <a:noFill/>
-        </p:spPr>
-        <p:txBody>
-          <a:bodyPr wrap="square">
-            <a:spAutoFit/>
-          </a:bodyPr>
-          <a:lstStyle/>
-          <a:p>
-            <a:pPr marL="292608" indent="-292608">
-              <a:lnSpc>
-                <a:spcPct val="108000"/>
-              </a:lnSpc>
-              <a:spcAft>
-                <a:spcPts val="400"/>
-              </a:spcAft>
-              <a:buClr>
-                <a:srgbClr val="1E6FE8"/>
-              </a:buClr>
-              <a:buFont typeface="Helvetica"/>
-              <a:buChar char="•"/>
-            </a:pPr>
-            <a:r>
-              <a:rPr sz="2000" b="0" i="0">
-                <a:solidFill>
-                  <a:srgbClr val="0F1C3F"/>
-                </a:solidFill>
-                <a:latin typeface="Helvetica"/>
-              </a:rPr>
-              <a:t>$2,45 / 1K mẫu</a:t>
-            </a:r>
-          </a:p>
-          <a:p>
-            <a:pPr marL="292608" indent="-292608">
-              <a:lnSpc>
-                <a:spcPct val="108000"/>
-              </a:lnSpc>
-              <a:spcAft>
-                <a:spcPts val="400"/>
-              </a:spcAft>
-              <a:buClr>
-                <a:srgbClr val="1E6FE8"/>
-              </a:buClr>
-              <a:buFont typeface="Helvetica"/>
-              <a:buChar char="•"/>
-            </a:pPr>
-            <a:r>
-              <a:rPr sz="2000" b="0" i="0">
-                <a:solidFill>
-                  <a:srgbClr val="0F1C3F"/>
-                </a:solidFill>
-                <a:latin typeface="Helvetica"/>
-              </a:rPr>
-              <a:t>Lai k=3: 59,5%</a:t>
-            </a:r>
-          </a:p>
-          <a:p>
-            <a:pPr marL="292608" indent="-292608">
-              <a:lnSpc>
-                <a:spcPct val="108000"/>
-              </a:lnSpc>
-              <a:spcAft>
-                <a:spcPts val="400"/>
-              </a:spcAft>
-              <a:buClr>
-                <a:srgbClr val="1E6FE8"/>
-              </a:buClr>
-              <a:buFont typeface="Helvetica"/>
-              <a:buChar char="•"/>
-            </a:pPr>
-            <a:r>
-              <a:rPr sz="2000" b="0" i="0">
-                <a:solidFill>
-                  <a:srgbClr val="0F1C3F"/>
-                </a:solidFill>
-                <a:latin typeface="Helvetica"/>
-              </a:rPr>
-              <a:t>Chỉ luật: 23,9%, $0</a:t>
-            </a:r>
-          </a:p>
-        </p:txBody>
-      </p:sp>
-      <p:sp>
-        <p:nvSpPr>
-          <p:cNvPr id="16" name="Rounded Rectangle 15"/>
-          <p:cNvSpPr/>
-          <p:nvPr/>
-        </p:nvSpPr>
-        <p:spPr>
-          <a:xfrm>
-            <a:off x="8046719" y="1691640"/>
-            <a:ext cx="3566160" cy="4343400"/>
-          </a:xfrm>
-          <a:prstGeom prst="roundRect">
-            <a:avLst>
-              <a:gd name="adj" fmla="val 8000"/>
-            </a:avLst>
-          </a:prstGeom>
-          <a:solidFill>
-            <a:srgbClr val="EAF2FF"/>
-          </a:solidFill>
-          <a:ln>
-            <a:noFill/>
-          </a:ln>
-          <a:effectLst/>
-        </p:spPr>
-        <p:style>
-          <a:lnRef idx="1">
-            <a:schemeClr val="accent1"/>
-          </a:lnRef>
-          <a:fillRef idx="3">
-            <a:schemeClr val="accent1"/>
-          </a:fillRef>
-          <a:effectRef idx="2">
-            <a:schemeClr val="accent1"/>
-          </a:effectRef>
-          <a:fontRef idx="minor">
-            <a:schemeClr val="lt1"/>
-          </a:fontRef>
-        </p:style>
-        <p:txBody>
-          <a:bodyPr rtlCol="0" anchor="ctr"/>
-          <a:lstStyle/>
-          <a:p>
-            <a:pPr algn="ctr"/>
-          </a:p>
-        </p:txBody>
-      </p:sp>
-      <p:sp>
-        <p:nvSpPr>
-          <p:cNvPr id="17" name="TextBox 16"/>
-          <p:cNvSpPr txBox="1"/>
-          <p:nvPr/>
-        </p:nvSpPr>
-        <p:spPr>
-          <a:xfrm>
-            <a:off x="8275319" y="1828800"/>
-            <a:ext cx="3108960" cy="457200"/>
-          </a:xfrm>
-          <a:prstGeom prst="rect">
-            <a:avLst/>
-          </a:prstGeom>
-          <a:noFill/>
-        </p:spPr>
-        <p:txBody>
-          <a:bodyPr wrap="square" anchor="t" lIns="45720" rIns="45720" tIns="27432" bIns="27432">
-            <a:spAutoFit/>
-          </a:bodyPr>
-          <a:lstStyle/>
-          <a:p>
-            <a:pPr algn="l">
-              <a:lnSpc>
-                <a:spcPct val="110000"/>
-              </a:lnSpc>
-            </a:pPr>
-            <a:r>
-              <a:rPr sz="2200" b="1" i="0">
-                <a:solidFill>
-                  <a:srgbClr val="144FB0"/>
-                </a:solidFill>
-                <a:latin typeface="Helvetica"/>
-              </a:rPr>
-              <a:t>RQ3 · Mở rộng</a:t>
-            </a:r>
-          </a:p>
-        </p:txBody>
-      </p:sp>
-      <p:sp>
-        <p:nvSpPr>
-          <p:cNvPr id="18" name="TextBox 17"/>
-          <p:cNvSpPr txBox="1"/>
-          <p:nvPr/>
-        </p:nvSpPr>
-        <p:spPr>
-          <a:xfrm>
-            <a:off x="8275319" y="2331720"/>
-            <a:ext cx="3200400" cy="777240"/>
-          </a:xfrm>
-          <a:prstGeom prst="rect">
-            <a:avLst/>
-          </a:prstGeom>
-          <a:noFill/>
-        </p:spPr>
-        <p:txBody>
-          <a:bodyPr wrap="square" anchor="t" lIns="45720" rIns="45720" tIns="27432" bIns="27432">
-            <a:spAutoFit/>
-          </a:bodyPr>
-          <a:lstStyle/>
-          <a:p>
-            <a:pPr algn="l">
-              <a:lnSpc>
-                <a:spcPct val="110000"/>
-              </a:lnSpc>
-            </a:pPr>
-            <a:r>
-              <a:rPr sz="4000" b="1" i="0">
-                <a:solidFill>
-                  <a:srgbClr val="1E6FE8"/>
-                </a:solidFill>
-                <a:latin typeface="Helvetica"/>
-              </a:rPr>
-              <a:t>3 ms</a:t>
-            </a:r>
-          </a:p>
-        </p:txBody>
-      </p:sp>
-      <p:sp>
-        <p:nvSpPr>
-          <p:cNvPr id="19" name="TextBox 18"/>
-          <p:cNvSpPr txBox="1"/>
-          <p:nvPr/>
-        </p:nvSpPr>
-        <p:spPr>
-          <a:xfrm>
-            <a:off x="8275319" y="3108960"/>
-            <a:ext cx="3108960" cy="457200"/>
-          </a:xfrm>
-          <a:prstGeom prst="rect">
-            <a:avLst/>
-          </a:prstGeom>
-          <a:noFill/>
-        </p:spPr>
-        <p:txBody>
-          <a:bodyPr wrap="square" anchor="t" lIns="45720" rIns="45720" tIns="27432" bIns="27432">
-            <a:spAutoFit/>
-          </a:bodyPr>
-          <a:lstStyle/>
-          <a:p>
-            <a:pPr algn="l">
-              <a:lnSpc>
-                <a:spcPct val="110000"/>
-              </a:lnSpc>
-            </a:pPr>
-            <a:r>
-              <a:rPr sz="2000" b="0" i="0">
-                <a:solidFill>
-                  <a:srgbClr val="5B6B82"/>
-                </a:solidFill>
-                <a:latin typeface="Helvetica"/>
-              </a:rPr>
-              <a:t>P50 mỗi định lý với REPL</a:t>
-            </a:r>
-          </a:p>
-        </p:txBody>
-      </p:sp>
-      <p:sp>
-        <p:nvSpPr>
-          <p:cNvPr id="20" name="TextBox 19"/>
-          <p:cNvSpPr txBox="1"/>
-          <p:nvPr/>
-        </p:nvSpPr>
-        <p:spPr>
-          <a:xfrm>
-            <a:off x="8275319" y="3794760"/>
-            <a:ext cx="3154680" cy="2194560"/>
-          </a:xfrm>
-          <a:prstGeom prst="rect">
-            <a:avLst/>
-          </a:prstGeom>
-          <a:noFill/>
-        </p:spPr>
-        <p:txBody>
-          <a:bodyPr wrap="square">
-            <a:spAutoFit/>
-          </a:bodyPr>
-          <a:lstStyle/>
-          <a:p>
-            <a:pPr marL="292608" indent="-292608">
-              <a:lnSpc>
-                <a:spcPct val="108000"/>
-              </a:lnSpc>
-              <a:spcAft>
-                <a:spcPts val="400"/>
-              </a:spcAft>
-              <a:buClr>
-                <a:srgbClr val="1E6FE8"/>
-              </a:buClr>
-              <a:buFont typeface="Helvetica"/>
-              <a:buChar char="•"/>
-            </a:pPr>
-            <a:r>
-              <a:rPr sz="2000" b="0" i="0">
-                <a:solidFill>
-                  <a:srgbClr val="0F1C3F"/>
-                </a:solidFill>
-                <a:latin typeface="Helvetica"/>
-              </a:rPr>
-              <a:t>Chạy nguội: 63–107 s</a:t>
-            </a:r>
-          </a:p>
-          <a:p>
-            <a:pPr marL="292608" indent="-292608">
-              <a:lnSpc>
-                <a:spcPct val="108000"/>
-              </a:lnSpc>
-              <a:spcAft>
-                <a:spcPts val="400"/>
-              </a:spcAft>
-              <a:buClr>
-                <a:srgbClr val="1E6FE8"/>
-              </a:buClr>
-              <a:buFont typeface="Helvetica"/>
-              <a:buChar char="•"/>
-            </a:pPr>
-            <a:r>
-              <a:rPr sz="2000" b="0" i="0">
-                <a:solidFill>
-                  <a:srgbClr val="0F1C3F"/>
-                </a:solidFill>
-                <a:latin typeface="Helvetica"/>
-              </a:rPr>
-              <a:t>10K: 1,52 → 2,86 mẫu/s</a:t>
-            </a:r>
-          </a:p>
-          <a:p>
-            <a:pPr marL="292608" indent="-292608">
-              <a:lnSpc>
-                <a:spcPct val="108000"/>
-              </a:lnSpc>
-              <a:spcAft>
-                <a:spcPts val="400"/>
-              </a:spcAft>
-              <a:buClr>
-                <a:srgbClr val="1E6FE8"/>
-              </a:buClr>
-              <a:buFont typeface="Helvetica"/>
-              <a:buChar char="•"/>
-            </a:pPr>
-            <a:r>
-              <a:rPr sz="2000" b="0" i="0">
-                <a:solidFill>
-                  <a:srgbClr val="0F1C3F"/>
-                </a:solidFill>
-                <a:latin typeface="Helvetica"/>
-              </a:rPr>
-              <a:t>P95 3,1 → 6,5 s, nghẽn CPU</a:t>
-            </a:r>
-          </a:p>
-        </p:txBody>
-      </p:sp>
-      <p:sp>
-        <p:nvSpPr>
-          <p:cNvPr id="21" name="TextBox 20"/>
-          <p:cNvSpPr txBox="1"/>
-          <p:nvPr/>
-        </p:nvSpPr>
-        <p:spPr>
-          <a:xfrm>
-            <a:off x="548640" y="6108192"/>
-            <a:ext cx="10058400" cy="411480"/>
-          </a:xfrm>
-          <a:prstGeom prst="rect">
-            <a:avLst/>
-          </a:prstGeom>
-          <a:noFill/>
-        </p:spPr>
-        <p:txBody>
-          <a:bodyPr wrap="square" anchor="t" lIns="45720" rIns="45720" tIns="27432" bIns="27432">
-            <a:spAutoFit/>
-          </a:bodyPr>
-          <a:lstStyle/>
-          <a:p>
-            <a:pPr algn="l">
-              <a:lnSpc>
-                <a:spcPct val="110000"/>
-              </a:lnSpc>
-            </a:pPr>
-            <a:r>
-              <a:rPr sz="2000" b="0" i="0">
-                <a:solidFill>
-                  <a:srgbClr val="5B6B82"/>
-                </a:solidFill>
-                <a:latin typeface="Helvetica"/>
-              </a:rPr>
-              <a:t>Biểu đồ chi tiết: phụ lục P1–P3</a:t>
+              <a:t>Chỉ kém ở SEM_06, TAC_07: cần viết chứng minh mới</a:t>
             </a:r>
           </a:p>
         </p:txBody>

</xml_diff>

<commit_message>
docs(slides): generated talk script with synced speaker notes
- slides/talk_script_content.py: single source for the speech per slide,
  speaker, short notes, cuttable paragraphs, glossary and symbol table
- slides/build_talk_script.py builds KichBan_ThuyetTrinh_Nhom6.docx:
  title and speaker table, usage notes, timing table (160 syllables/min),
  plain summary read from README, speech per slide with grey annotations
  on the first use of each term, appendix A computed from run records,
  configs and the cost ledger, glossary and symbol appendices
- the build stops when the slide count, the pptx notes or the glossary
  usage do not match; build_slides.py now writes "<speaker>: <notes>"
- README: "Tóm tắt dễ hiểu" section (what, what we did, results)
- slides/talk_to_pdf.sh exports the PDF with Word (13 pages)

Talk: 16:30 at 160 syllables/min, 15:25 without the cuttable paragraphs.

Co-Authored-By: Claude Opus 5.5 <noreply@anthropic.com>
</commit_message>
<xml_diff>
--- a/slides/Slides_Nhom6_VerifierRepair.pptx
+++ b/slides/Slides_Nhom6_VerifierRepair.pptx
@@ -518,7 +518,7 @@
           <a:lstStyle/>
           <a:p>
             <a:r>
-              <a:t>Tâm: giới thiệu đề tài, môn học, giảng viên, nhóm. Một câu: hệ thống sửa chứng minh Lean 4 hàng loạt, chỉ chấp nhận bản sửa được Lean kiểm chứng và giữ nguyên đề, dưới giới hạn chi phí và độ trễ.</a:t>
+              <a:t>Tâm: Chào; đề tài; tóm tắt dễ hiểu 1 phút; lộ trình bốn phần.</a:t>
             </a:r>
           </a:p>
         </p:txBody>
@@ -588,7 +588,7 @@
           <a:lstStyle/>
           <a:p>
             <a:r>
-              <a:t>Tâm: trục x là chi phí LLM cho 1.000 mẫu, trục y là tỷ lệ thành công. Biên đi từ chỉ luật $0 qua lai k=1, LLM k=1, lai k=3 tới LLM k=3. Blind và Gemini 3.6 Flash nằm dưới biên: đắt hơn mà kém hơn. k = 3 thêm 11 điểm so với k = 1; 82,7% thành công đến ngay lần thử đầu. Biểu đồ ablation đầy đủ ở phụ lục P1.</a:t>
+              <a:t>Tâm: RQ2: biên Pareto; LLM k=3 65,1% với 2,45 USD/1K; lai k=3 59,5%; chỉ luật 23,9%, 0 USD; Gemini 3.6 Flash 36,6%.</a:t>
             </a:r>
           </a:p>
         </p:txBody>
@@ -658,7 +658,7 @@
           <a:lstStyle/>
           <a:p>
             <a:r>
-              <a:t>Dũng: REPL khớp 74/74 với chạy nguội. 3 mức dữ liệu x 3 mức worker x 3 lần lặp, chênh lệch dưới 4%. Từ 2 lên 4 worker chỉ thêm 7–11% thông lượng, P95 phục vụ tăng gấp đôi vì 4 REPL tranh 4 vCPU. USS 12,6 → 21,1 GB. Mở rộng tiếp cần nhiều máy. P50 và P95 theo từng mức ở phụ lục P2.</a:t>
+              <a:t>Dũng: RQ3: REPL P50 3 ms, P95 23 ms so với 63–107 s; 10K: 1,52 lên 2,86 mẫu/s, tăng tốc 1,76 lần với 2 worker, 1,88 lần với 4; P95 3,1 lên 6,5 s; nghẽn CPU.</a:t>
             </a:r>
           </a:p>
         </p:txBody>
@@ -728,7 +728,7 @@
           <a:lstStyle/>
           <a:p>
             <a:r>
-              <a:t>Trung + Khamsing: luật được thử trước trên 203/284 mẫu nhưng chỉ đúng 33%; với k = 1 luật sai là hết lượt. R0 97%, R7 100%; R2–R6 0% trên tệp hoàn chỉnh. Ablation bộ phân loại phát lại log, không gọi thêm LLM: phân loại đúng hơn giảm 31% token nhưng gửi nhiều mẫu hơn sang luật kém. Cải tiến: chỉ dùng luật chính xác, đo trên train.</a:t>
+              <a:t>Trung: R0 97%, R7 100%, R1 27%, R2/R3 0%; 203/284 mẫu sang luật, đúng 33%; ablation: khớp nhãn 72,3 lên 96,3%, token −31%, lai k=1 34,9 xuống 30,3%.</a:t>
             </a:r>
           </a:p>
         </p:txBody>
@@ -798,7 +798,7 @@
           <a:lstStyle/>
           <a:p>
             <a:r>
-              <a:t>Khamsing/Tâm: trong các mẫu thất bại, 17–26% bản sửa của LLM đổi phát biểu và 10–24% chèn sorry hoặc cấu trúc cấm. LLM k = 3: biên dịch 75,0% nhưng thành công thật 65,1%.</a:t>
+              <a:t>Khamsing: LLM k=3: biên dịch 75,0% nhưng thành công thật 65,1%; trong mẫu thất bại 17–26% đổi đề, 10–24% chèn sorry; kiểm toán chặn sorry, admit, axiom, native_decide.</a:t>
             </a:r>
           </a:p>
         </p:txBody>
@@ -868,7 +868,7 @@
           <a:lstStyle/>
           <a:p>
             <a:r>
-              <a:t>Tâm: ba bài học; phần bàn giao và tái lập: scripts/repair_batch.py nhận file của Nhóm 5 theo data contract, đầu ra repaired-v1 cho Nhóm 7/8, Docker, 121 test, notebook Kaggle, run record và log phát lại; hướng phát triển.</a:t>
+              <a:t>Tâm: Ba bài học; bàn giao: cổng Nhóm 5, repaired-v1, Docker, 121 test, notebook, log phát lại; hướng phát triển.</a:t>
             </a:r>
           </a:p>
         </p:txBody>
@@ -938,7 +938,7 @@
           <a:lstStyle/>
           <a:p>
             <a:r>
-              <a:t>Cả nhóm: cảm ơn, mời hỏi đáp; Tâm điều phối người trả lời theo bảng; bộ câu hỏi trong slides/defense_qa.md. Phụ lục P1–P2 sau slide này, chỉ mở khi được hỏi.</a:t>
+              <a:t>Tâm: Cảm ơn; chuyển câu hỏi theo bảng: Tâm, Dũng, Trung, Tùng, Khamsing, Nounou. Phụ lục P1–P2 chỉ mở khi được hỏi.</a:t>
             </a:r>
           </a:p>
         </p:txBody>
@@ -1008,7 +1008,7 @@
           <a:lstStyle/>
           <a:p>
             <a:r>
-              <a:t>Cột xanh là biên dịch, cột cam là thành công đã kiểm toán; khoảng cách giữa hai cột là phần kiểm toán chặn. k = 3 thêm 11 điểm % so với k = 1; 82,7% thành công đến ngay lần thử đầu, 12,4% ở lần 2.</a:t>
+              <a:t>Tâm: Phụ lục, chỉ mở khi được hỏi: biên dịch so với thành công đã kiểm toán theo từng cấu hình.</a:t>
             </a:r>
           </a:p>
         </p:txBody>
@@ -1078,7 +1078,7 @@
           <a:lstStyle/>
           <a:p>
             <a:r>
-              <a:t>P50 và P95 thời gian phục vụ mỗi mẫu ở 100, 1K, 10K với 1, 2, 4 worker, trung vị và min–max của 3 lần lặp. Ở mức 100 P95 cao vì mẫu ít, đuôi do vài định lý nặng chi phối.</a:t>
+              <a:t>Dũng: Phụ lục, chỉ mở khi được hỏi: P50 và P95 thời gian phục vụ ở 100, 1K, 10K với 1, 2, 4 worker.</a:t>
             </a:r>
           </a:p>
         </p:txBody>
@@ -1148,7 +1148,7 @@
           <a:lstStyle/>
           <a:p>
             <a:r>
-              <a:t>Tâm: vị trí Nhóm 6 trong chuỗi AI4Math. Mục tiêu bài tập: sửa tự động nhưng đáng tin, nghĩa là chỉ nhận bản sửa Lean chấp nhận và giữ nguyên đề, trong giới hạn chi phí token và độ trễ, tái lập và bàn giao được. Ba câu hỏi nghiên cứu.</a:t>
+              <a:t>Tâm: Vị trí giữa Nhóm 5 và Nhóm 7/8; ba mục tiêu; RQ1 đến RQ3.</a:t>
             </a:r>
           </a:p>
         </p:txBody>
@@ -1218,7 +1218,7 @@
           <a:lstStyle/>
           <a:p>
             <a:r>
-              <a:t>Tâm: trước khi vào chi tiết, đây là những gì nhóm xây dựng và đối chiếu với 6 tiêu chí nghiệm thu tối thiểu trong hướng dẫn bài tập lớn. Toàn bộ thực nghiệm tốn 2,97 USD, 121 test tự động.</a:t>
+              <a:t>Tâm: Bốn thành phần đã xây dựng; đạt 6/6 tiêu chí nghiệm thu; 2,97 USD, 121 test, 67 run record.</a:t>
             </a:r>
           </a:p>
         </p:txBody>
@@ -1288,7 +1288,7 @@
           <a:lstStyle/>
           <a:p>
             <a:r>
-              <a:t>Tâm: bốn con số làm nên bài toán Big Data. Kiểm chứng nguội nạp Mathlib mỗi tệp; số ứng viên 10^4; mỗi lần gọi LLM tốn token; log phải phát lại được để kiểm toán.</a:t>
+              <a:t>Dũng: Nút thắt: kiểm chứng nguội 63–107 s, 10.000 ứng viên, ~1.000 token mỗi lần, 67 run record.</a:t>
             </a:r>
           </a:p>
         </p:txBody>
@@ -1358,7 +1358,7 @@
           <a:lstStyle/>
           <a:p>
             <a:r>
-              <a:t>Nounou: chứng minh Goedel-Prover trên Lean Workbook, giấy phép MIT, kiểm chứng lại với Lean 4.35 còn 3.666 seed; 1.110 chứng minh cũ hỏng do Mathlib đổi tên là lỗi tự nhiên; 9 toán tử gây lỗi; nhãn từ thông báo Lean thật; chia theo định lý gốc; checksum SHA-256 trong manifest; mỗi lần chạy ghi run record.</a:t>
+              <a:t>Nounou: Nguồn MIT; 3.666 định lý gốc; 9 cách gây lỗi; 1.110 lỗi tự nhiên; nhãn khớp 94,4%; chia theo định lý gốc.</a:t>
             </a:r>
           </a:p>
         </p:txBody>
@@ -1428,7 +1428,7 @@
           <a:lstStyle/>
           <a:p>
             <a:r>
-              <a:t>Khamsing + Trung + Tùng: parser lấy lỗi gốc từ thông báo Lean, taxonomy 7 nhóm, thêm TAC_07; router gửi lỗi đơn giản cho luật 0 token, còn lại cho LLM có chẩn đoán; Lean REPL kiểm chứng; kiểm toán chặn sorry/axiom/đổi đề; vòng lặp tối đa k lần, dừng khi ứng viên lặp lại.</a:t>
+              <a:t>Khamsing: Năm bước: parser + taxonomy, router, luật/LLM, Lean REPL, kiểm toán; vòng lặp tối đa k lần, 300 s.</a:t>
             </a:r>
           </a:p>
         </p:txBody>
@@ -1498,7 +1498,7 @@
           <a:lstStyle/>
           <a:p>
             <a:r>
-              <a:t>Trung/Tùng/Khamsing: chạy slides/demo_script.md, phát lại log, $0. E000880: luật R0, 0 token. E000003: cùng loại lỗi, chỉ LLM, lần 1 lách bằng sorry bị chặn, lần 3 đúng, 4.583 token. E000197: đúng ở lần 2.</a:t>
+              <a:t>Trung: Demo phát lại log, 0 USD: E000880 luật R0, 0 token, 73 ms; E000003 LLM, lần 1 dùng sorry bị chặn, lần 3 đúng, 4.583 token; E000197 đúng ở lần 2, 779 token.</a:t>
             </a:r>
           </a:p>
         </p:txBody>
@@ -1568,7 +1568,7 @@
           <a:lstStyle/>
           <a:p>
             <a:r>
-              <a:t>Tâm: Kaggle CPU 4 vCPU / 31 GB; Gemini 3.5 Flash-Lite nhiệt độ 0; baseline bắt buộc = thử lại nguyên prompt đúng 1 lần; 3 lần lặp, báo trung vị và min–max; trần chi phí $8/tháng, tổng chi thực tế $2,97.</a:t>
+              <a:t>Tâm: Cùng dữ liệu, phần cứng, seed; 5 chiến lược; k 0/1/3, 3 mức, 1/2/4 worker, 3 lần; Kaggle 4 vCPU 31,3 GB; Gemini Flash-Lite; độ đo; giả thuyết H1–H3.</a:t>
             </a:r>
           </a:p>
         </p:txBody>
@@ -1638,7 +1638,7 @@
           <a:lstStyle/>
           <a:p>
             <a:r>
-              <a:t>Tùng: cùng 284 mẫu hold-out, k = 1, cùng model. Không có chẩn đoán, mô hình viết lại cả tệp, 783 token ra mỗi lần nên đắt hơn; có chẩn đoán, mô hình sửa cục bộ, 389 token. Lợi ích lớn ở SYN_01 47 → 85%, TMO_05 10 → 69%, IMP_02 3 → 34%; SEM_06 và TAC_07 hơi kém hơn vì cần viết chứng minh mới chứ không chỉ sửa chỗ lỗi.</a:t>
+              <a:t>Tùng: RQ1: 31,7% lên 53,9%, chi phí 2,05 xuống 1,13 USD/1K; 783 so với 389 token ra; theo nhóm lỗi: SYN_01, TMO_05, IMP_02 tăng mạnh, SEM_06 và TAC_07 hơi giảm.</a:t>
             </a:r>
           </a:p>
         </p:txBody>

</xml_diff>